<commit_message>
Atualiza apresentacao wisard aa at
</commit_message>
<xml_diff>
--- a/output/apresentacao_wisard_aa_at.pptx
+++ b/output/apresentacao_wisard_aa_at.pptx
@@ -5,7 +5,7 @@
     <p:sldMasterId id="2147483648" r:id="rId1"/>
   </p:sldMasterIdLst>
   <p:notesMasterIdLst>
-    <p:notesMasterId r:id="rId15"/>
+    <p:notesMasterId r:id="rId12"/>
   </p:notesMasterIdLst>
   <p:sldIdLst>
     <p:sldId id="256" r:id="rId2"/>
@@ -17,10 +17,7 @@
     <p:sldId id="261" r:id="rId8"/>
     <p:sldId id="262" r:id="rId9"/>
     <p:sldId id="263" r:id="rId10"/>
-    <p:sldId id="264" r:id="rId11"/>
-    <p:sldId id="265" r:id="rId12"/>
-    <p:sldId id="266" r:id="rId13"/>
-    <p:sldId id="267" r:id="rId14"/>
+    <p:sldId id="267" r:id="rId11"/>
   </p:sldIdLst>
   <p:sldSz cx="12192000" cy="6858000"/>
   <p:notesSz cx="6858000" cy="9144000"/>
@@ -119,6 +116,11 @@
       </a:defRPr>
     </a:lvl9pPr>
   </p:defaultTextStyle>
+  <p:extLst>
+    <p:ext uri="{EFAFB233-063F-42B5-8137-9DF3F51BA10A}">
+      <p15:sldGuideLst xmlns:p15="http://schemas.microsoft.com/office/powerpoint/2012/main"/>
+    </p:ext>
+  </p:extLst>
 </p:presentation>
 </file>
 
@@ -394,276 +396,6 @@
 </file>
 
 <file path=ppt/notesSlides/notesSlide10.xml><?xml version="1.0" encoding="utf-8"?>
-<p:notes xmlns:a="http://schemas.openxmlformats.org/drawingml/2006/main" xmlns:r="http://schemas.openxmlformats.org/officeDocument/2006/relationships" xmlns:p="http://schemas.openxmlformats.org/presentationml/2006/main">
-  <p:cSld>
-    <p:spTree>
-      <p:nvGrpSpPr>
-        <p:cNvPr id="1" name=""/>
-        <p:cNvGrpSpPr/>
-        <p:nvPr/>
-      </p:nvGrpSpPr>
-      <p:grpSpPr>
-        <a:xfrm>
-          <a:off x="0" y="0"/>
-          <a:ext cx="0" cy="0"/>
-          <a:chOff x="0" y="0"/>
-          <a:chExt cx="0" cy="0"/>
-        </a:xfrm>
-      </p:grpSpPr>
-      <p:sp>
-        <p:nvSpPr>
-          <p:cNvPr id="2" name="Slide Image Placeholder 1"/>
-          <p:cNvSpPr>
-            <a:spLocks noGrp="1" noRot="1" noChangeAspect="1"/>
-          </p:cNvSpPr>
-          <p:nvPr>
-            <p:ph type="sldImg"/>
-          </p:nvPr>
-        </p:nvSpPr>
-        <p:spPr/>
-      </p:sp>
-      <p:sp>
-        <p:nvSpPr>
-          <p:cNvPr id="3" name="Notes Placeholder 2"/>
-          <p:cNvSpPr>
-            <a:spLocks noGrp="1"/>
-          </p:cNvSpPr>
-          <p:nvPr>
-            <p:ph type="body" idx="1"/>
-          </p:nvPr>
-        </p:nvSpPr>
-        <p:spPr/>
-        <p:txBody>
-          <a:bodyPr/>
-          <a:lstStyle/>
-          <a:p>
-            <a:r>
-              <a:t>Faça explicitamente a ponte: AA1 inspira treinamento incremental e confiança; AA2 fundamenta que a representação e a robustez importam. O AT não promete uma nova WiSARD clássica; a contribuição é um fluxo operacional auditável.</a:t>
-            </a:r>
-          </a:p>
-          <a:p>
-            <a:endParaRPr/>
-          </a:p>
-          <a:p>
-            <a:r>
-              <a:t>[Sources]</a:t>
-            </a:r>
-          </a:p>
-          <a:p>
-            <a:r>
-              <a:t>dos Anjos, J. S. Classificação Incremental e Auditável de Crimes em Notícias Institucionais com Memória WNN e LLM Residual. Trabalho final (arquivo fornecido).</a:t>
-            </a:r>
-          </a:p>
-        </p:txBody>
-      </p:sp>
-      <p:sp>
-        <p:nvSpPr>
-          <p:cNvPr id="4" name="Slide Number Placeholder 3"/>
-          <p:cNvSpPr>
-            <a:spLocks noGrp="1"/>
-          </p:cNvSpPr>
-          <p:nvPr>
-            <p:ph type="sldNum" idx="5"/>
-          </p:nvPr>
-        </p:nvSpPr>
-        <p:spPr/>
-        <p:txBody>
-          <a:bodyPr/>
-          <a:lstStyle/>
-          <a:p>
-            <a:endParaRPr/>
-          </a:p>
-        </p:txBody>
-      </p:sp>
-    </p:spTree>
-  </p:cSld>
-  <p:clrMapOvr>
-    <a:masterClrMapping/>
-  </p:clrMapOvr>
-</p:notes>
-</file>
-
-<file path=ppt/notesSlides/notesSlide11.xml><?xml version="1.0" encoding="utf-8"?>
-<p:notes xmlns:a="http://schemas.openxmlformats.org/drawingml/2006/main" xmlns:r="http://schemas.openxmlformats.org/officeDocument/2006/relationships" xmlns:p="http://schemas.openxmlformats.org/presentationml/2006/main">
-  <p:cSld>
-    <p:spTree>
-      <p:nvGrpSpPr>
-        <p:cNvPr id="1" name=""/>
-        <p:cNvGrpSpPr/>
-        <p:nvPr/>
-      </p:nvGrpSpPr>
-      <p:grpSpPr>
-        <a:xfrm>
-          <a:off x="0" y="0"/>
-          <a:ext cx="0" cy="0"/>
-          <a:chOff x="0" y="0"/>
-          <a:chExt cx="0" cy="0"/>
-        </a:xfrm>
-      </p:grpSpPr>
-      <p:sp>
-        <p:nvSpPr>
-          <p:cNvPr id="2" name="Slide Image Placeholder 1"/>
-          <p:cNvSpPr>
-            <a:spLocks noGrp="1" noRot="1" noChangeAspect="1"/>
-          </p:cNvSpPr>
-          <p:nvPr>
-            <p:ph type="sldImg"/>
-          </p:nvPr>
-        </p:nvSpPr>
-        <p:spPr/>
-      </p:sp>
-      <p:sp>
-        <p:nvSpPr>
-          <p:cNvPr id="3" name="Notes Placeholder 2"/>
-          <p:cNvSpPr>
-            <a:spLocks noGrp="1"/>
-          </p:cNvSpPr>
-          <p:nvPr>
-            <p:ph type="body" idx="1"/>
-          </p:nvPr>
-        </p:nvSpPr>
-        <p:spPr/>
-        <p:txBody>
-          <a:bodyPr/>
-          <a:lstStyle/>
-          <a:p>
-            <a:r>
-              <a:t>A fundação usa 10% da base e a reserva, 90%, é processada em lotes. A WNN aceita só decisão com evidência suficiente; os casos restantes vão à LLM. As decisões de LLM podem gerar marcadores novos, mas a atualização é controlada e registrada.</a:t>
-            </a:r>
-          </a:p>
-          <a:p>
-            <a:endParaRPr/>
-          </a:p>
-          <a:p>
-            <a:r>
-              <a:t>[Sources]</a:t>
-            </a:r>
-          </a:p>
-          <a:p>
-            <a:r>
-              <a:t>dos Anjos, J. S. Classificação Incremental e Auditável de Crimes em Notícias Institucionais com Memória WNN e LLM Residual. Trabalho final (arquivo fornecido).</a:t>
-            </a:r>
-          </a:p>
-        </p:txBody>
-      </p:sp>
-      <p:sp>
-        <p:nvSpPr>
-          <p:cNvPr id="4" name="Slide Number Placeholder 3"/>
-          <p:cNvSpPr>
-            <a:spLocks noGrp="1"/>
-          </p:cNvSpPr>
-          <p:nvPr>
-            <p:ph type="sldNum" idx="5"/>
-          </p:nvPr>
-        </p:nvSpPr>
-        <p:spPr/>
-        <p:txBody>
-          <a:bodyPr/>
-          <a:lstStyle/>
-          <a:p>
-            <a:endParaRPr/>
-          </a:p>
-        </p:txBody>
-      </p:sp>
-    </p:spTree>
-  </p:cSld>
-  <p:clrMapOvr>
-    <a:masterClrMapping/>
-  </p:clrMapOvr>
-</p:notes>
-</file>
-
-<file path=ppt/notesSlides/notesSlide12.xml><?xml version="1.0" encoding="utf-8"?>
-<p:notes xmlns:a="http://schemas.openxmlformats.org/drawingml/2006/main" xmlns:r="http://schemas.openxmlformats.org/officeDocument/2006/relationships" xmlns:p="http://schemas.openxmlformats.org/presentationml/2006/main">
-  <p:cSld>
-    <p:spTree>
-      <p:nvGrpSpPr>
-        <p:cNvPr id="1" name=""/>
-        <p:cNvGrpSpPr/>
-        <p:nvPr/>
-      </p:nvGrpSpPr>
-      <p:grpSpPr>
-        <a:xfrm>
-          <a:off x="0" y="0"/>
-          <a:ext cx="0" cy="0"/>
-          <a:chOff x="0" y="0"/>
-          <a:chExt cx="0" cy="0"/>
-        </a:xfrm>
-      </p:grpSpPr>
-      <p:sp>
-        <p:nvSpPr>
-          <p:cNvPr id="2" name="Slide Image Placeholder 1"/>
-          <p:cNvSpPr>
-            <a:spLocks noGrp="1" noRot="1" noChangeAspect="1"/>
-          </p:cNvSpPr>
-          <p:nvPr>
-            <p:ph type="sldImg"/>
-          </p:nvPr>
-        </p:nvSpPr>
-        <p:spPr/>
-      </p:sp>
-      <p:sp>
-        <p:nvSpPr>
-          <p:cNvPr id="3" name="Notes Placeholder 2"/>
-          <p:cNvSpPr>
-            <a:spLocks noGrp="1"/>
-          </p:cNvSpPr>
-          <p:nvPr>
-            <p:ph type="body" idx="1"/>
-          </p:nvPr>
-        </p:nvSpPr>
-        <p:spPr/>
-        <p:txBody>
-          <a:bodyPr/>
-          <a:lstStyle/>
-          <a:p>
-            <a:r>
-              <a:t>Foram 15 lotes de aproximadamente 500 notícias. 1.246 dos 1.247 residuais demandaram chamadas de LLM. A afirmação correta é que houve cobertura de 83,33% pela WNN, não acurácia de 83,33%, porque ainda não existe uma amostra de referência integralmente validada por especialistas.</a:t>
-            </a:r>
-          </a:p>
-          <a:p>
-            <a:endParaRPr/>
-          </a:p>
-          <a:p>
-            <a:r>
-              <a:t>[Sources]</a:t>
-            </a:r>
-          </a:p>
-          <a:p>
-            <a:r>
-              <a:t>dos Anjos, J. S. Classificação Incremental e Auditável de Crimes em Notícias Institucionais com Memória WNN e LLM Residual. Trabalho final (arquivo fornecido).</a:t>
-            </a:r>
-          </a:p>
-        </p:txBody>
-      </p:sp>
-      <p:sp>
-        <p:nvSpPr>
-          <p:cNvPr id="4" name="Slide Number Placeholder 3"/>
-          <p:cNvSpPr>
-            <a:spLocks noGrp="1"/>
-          </p:cNvSpPr>
-          <p:nvPr>
-            <p:ph type="sldNum" idx="5"/>
-          </p:nvPr>
-        </p:nvSpPr>
-        <p:spPr/>
-        <p:txBody>
-          <a:bodyPr/>
-          <a:lstStyle/>
-          <a:p>
-            <a:endParaRPr/>
-          </a:p>
-        </p:txBody>
-      </p:sp>
-    </p:spTree>
-  </p:cSld>
-  <p:clrMapOvr>
-    <a:masterClrMapping/>
-  </p:clrMapOvr>
-</p:notes>
-</file>
-
-<file path=ppt/notesSlides/notesSlide13.xml><?xml version="1.0" encoding="utf-8"?>
 <p:notes xmlns:a="http://schemas.openxmlformats.org/drawingml/2006/main" xmlns:r="http://schemas.openxmlformats.org/officeDocument/2006/relationships" xmlns:p="http://schemas.openxmlformats.org/presentationml/2006/main">
   <p:cSld>
     <p:spTree>
@@ -2213,10 +1945,10 @@
       </p:grpSpPr>
       <p:sp>
         <p:nvSpPr>
-          <p:cNvPr id="16" name="Retângulo 15">
-            <a:extLst>
-              <a:ext uri="{FF2B5EF4-FFF2-40B4-BE49-F238E27FC236}">
-                <a16:creationId xmlns:a16="http://schemas.microsoft.com/office/drawing/2014/main" id="{6EDE3309-C013-47C6-A9EF-F5F2CF61D7CD}"/>
+          <p:cNvPr id="13" name="Retângulo 12">
+            <a:extLst>
+              <a:ext uri="{FF2B5EF4-FFF2-40B4-BE49-F238E27FC236}">
+                <a16:creationId xmlns:a16="http://schemas.microsoft.com/office/drawing/2014/main" id="{46C21316-E056-48D1-9FDE-9A5F3984F9A1}"/>
               </a:ext>
             </a:extLst>
           </p:cNvPr>
@@ -2256,7 +1988,7 @@
           <p:cNvPr id="2" name="Retângulo 1">
             <a:extLst>
               <a:ext uri="{FF2B5EF4-FFF2-40B4-BE49-F238E27FC236}">
-                <a16:creationId xmlns:a16="http://schemas.microsoft.com/office/drawing/2014/main" id="{29CE64EE-277B-416C-8340-95D9793C570D}"/>
+                <a16:creationId xmlns:a16="http://schemas.microsoft.com/office/drawing/2014/main" id="{204EB892-48B7-4948-A354-BB225BF4773F}"/>
               </a:ext>
             </a:extLst>
           </p:cNvPr>
@@ -2302,7 +2034,7 @@
                 <a:ea typeface="Aptos"/>
                 <a:cs typeface="Aptos"/>
               </a:rPr>
-              <a:t>AT | PROBLEMA E CONTRIBUIÇÃO</a:t>
+              <a:t>SÍNTESE</a:t>
             </a:r>
           </a:p>
         </p:txBody>
@@ -2312,7 +2044,7 @@
           <p:cNvPr id="3" name="Retângulo 2">
             <a:extLst>
               <a:ext uri="{FF2B5EF4-FFF2-40B4-BE49-F238E27FC236}">
-                <a16:creationId xmlns:a16="http://schemas.microsoft.com/office/drawing/2014/main" id="{666B36A5-CDA9-4375-BA1D-B01B7FA0D726}"/>
+                <a16:creationId xmlns:a16="http://schemas.microsoft.com/office/drawing/2014/main" id="{903DB0B7-ECA4-4B30-B2FC-241A6CA28ACC}"/>
               </a:ext>
             </a:extLst>
           </p:cNvPr>
@@ -2358,7 +2090,7 @@
                 <a:ea typeface="Aptos"/>
                 <a:cs typeface="Aptos"/>
               </a:rPr>
-              <a:t>O AT usa os artigos como base para classificar crimes em notícias institucionais</a:t>
+              <a:t>A contribuição do AT é organizar eficiência, adaptação e auditoria em um único ciclo</a:t>
             </a:r>
           </a:p>
         </p:txBody>
@@ -2368,7 +2100,7 @@
           <p:cNvPr id="4" name="Retângulo 3">
             <a:extLst>
               <a:ext uri="{FF2B5EF4-FFF2-40B4-BE49-F238E27FC236}">
-                <a16:creationId xmlns:a16="http://schemas.microsoft.com/office/drawing/2014/main" id="{A08FBAAD-DF45-42C2-B268-A5E1A4AACE44}"/>
+                <a16:creationId xmlns:a16="http://schemas.microsoft.com/office/drawing/2014/main" id="{2F3A5D8F-C5A7-454E-A30D-DABF3AD6E9AA}"/>
               </a:ext>
             </a:extLst>
           </p:cNvPr>
@@ -2414,3028 +2146,6 @@
                 <a:ea typeface="Aptos"/>
                 <a:cs typeface="Aptos"/>
               </a:rPr>
-              <a:t>09</a:t>
-            </a:r>
-          </a:p>
-        </p:txBody>
-      </p:sp>
-      <p:sp>
-        <p:nvSpPr>
-          <p:cNvPr id="5" name="Retângulo 4">
-            <a:extLst>
-              <a:ext uri="{FF2B5EF4-FFF2-40B4-BE49-F238E27FC236}">
-                <a16:creationId xmlns:a16="http://schemas.microsoft.com/office/drawing/2014/main" id="{AC19BE0E-9F90-4784-8E70-11E9EF7B4450}"/>
-              </a:ext>
-            </a:extLst>
-          </p:cNvPr>
-          <p:cNvSpPr>
-            <a:spLocks noGrp="1"/>
-          </p:cNvSpPr>
-          <p:nvPr/>
-        </p:nvSpPr>
-        <p:spPr>
-          <a:xfrm>
-            <a:off x="857250" y="2143125"/>
-            <a:ext cx="1619250" cy="285750"/>
-          </a:xfrm>
-          <a:prstGeom prst="rect">
-            <a:avLst/>
-          </a:prstGeom>
-          <a:noFill/>
-          <a:ln w="0">
-            <a:noFill/>
-            <a:prstDash val="solid"/>
-          </a:ln>
-        </p:spPr>
-        <p:txBody>
-          <a:bodyPr anchor="t"/>
-          <a:lstStyle/>
-          <a:p>
-            <a:pPr algn="l">
-              <a:defRPr sz="1800" b="1">
-                <a:solidFill>
-                  <a:srgbClr val="2F5D8C"/>
-                </a:solidFill>
-                <a:latin typeface="Aptos"/>
-                <a:ea typeface="Aptos"/>
-                <a:cs typeface="Aptos"/>
-              </a:defRPr>
-            </a:pPr>
-            <a:r>
-              <a:rPr sz="1800" b="1">
-                <a:solidFill>
-                  <a:srgbClr val="2F5D8C"/>
-                </a:solidFill>
-                <a:latin typeface="Aptos"/>
-                <a:ea typeface="Aptos"/>
-                <a:cs typeface="Aptos"/>
-              </a:rPr>
-              <a:t>Pergunta</a:t>
-            </a:r>
-          </a:p>
-        </p:txBody>
-      </p:sp>
-      <p:sp>
-        <p:nvSpPr>
-          <p:cNvPr id="6" name="Retângulo 5">
-            <a:extLst>
-              <a:ext uri="{FF2B5EF4-FFF2-40B4-BE49-F238E27FC236}">
-                <a16:creationId xmlns:a16="http://schemas.microsoft.com/office/drawing/2014/main" id="{68C39EC0-D69B-4445-BBE5-85B111731272}"/>
-              </a:ext>
-            </a:extLst>
-          </p:cNvPr>
-          <p:cNvSpPr>
-            <a:spLocks noGrp="1"/>
-          </p:cNvSpPr>
-          <p:nvPr/>
-        </p:nvSpPr>
-        <p:spPr>
-          <a:xfrm>
-            <a:off x="857250" y="2600325"/>
-            <a:ext cx="4667250" cy="1095375"/>
-          </a:xfrm>
-          <a:prstGeom prst="rect">
-            <a:avLst/>
-          </a:prstGeom>
-          <a:noFill/>
-          <a:ln w="0">
-            <a:noFill/>
-            <a:prstDash val="solid"/>
-          </a:ln>
-        </p:spPr>
-        <p:txBody>
-          <a:bodyPr anchor="t"/>
-          <a:lstStyle/>
-          <a:p>
-            <a:pPr algn="l">
-              <a:defRPr sz="2250" b="1">
-                <a:solidFill>
-                  <a:srgbClr val="14213D"/>
-                </a:solidFill>
-                <a:latin typeface="Aptos"/>
-                <a:ea typeface="Aptos"/>
-                <a:cs typeface="Aptos"/>
-              </a:defRPr>
-            </a:pPr>
-            <a:r>
-              <a:rPr sz="2250" b="1">
-                <a:solidFill>
-                  <a:srgbClr val="14213D"/>
-                </a:solidFill>
-                <a:latin typeface="Aptos"/>
-                <a:ea typeface="Aptos"/>
-                <a:cs typeface="Aptos"/>
-              </a:rPr>
-              <a:t>Como classificar uma base institucional que cresce, reduzindo chamadas à LLM e preservando auditoria?</a:t>
-            </a:r>
-          </a:p>
-        </p:txBody>
-      </p:sp>
-      <p:sp>
-        <p:nvSpPr>
-          <p:cNvPr id="7" name="Retângulo: Cantos Arredondados 6">
-            <a:extLst>
-              <a:ext uri="{FF2B5EF4-FFF2-40B4-BE49-F238E27FC236}">
-                <a16:creationId xmlns:a16="http://schemas.microsoft.com/office/drawing/2014/main" id="{7A588FED-F66D-4640-95FE-54C3453E0974}"/>
-              </a:ext>
-            </a:extLst>
-          </p:cNvPr>
-          <p:cNvSpPr>
-            <a:spLocks noGrp="1"/>
-          </p:cNvSpPr>
-          <p:nvPr/>
-        </p:nvSpPr>
-        <p:spPr>
-          <a:xfrm>
-            <a:off x="6477000" y="2095500"/>
-            <a:ext cx="4191000" cy="2428875"/>
-          </a:xfrm>
-          <a:prstGeom prst="roundRect">
-            <a:avLst>
-              <a:gd name="adj" fmla="val 4706"/>
-            </a:avLst>
-          </a:prstGeom>
-          <a:solidFill>
-            <a:srgbClr val="FFFFFF"/>
-          </a:solidFill>
-          <a:ln w="9525">
-            <a:solidFill>
-              <a:srgbClr val="D9DEE5"/>
-            </a:solidFill>
-            <a:prstDash val="solid"/>
-          </a:ln>
-        </p:spPr>
-        <p:txBody>
-          <a:bodyPr/>
-          <a:lstStyle/>
-          <a:p>
-            <a:endParaRPr lang="pt-PT"/>
-          </a:p>
-        </p:txBody>
-      </p:sp>
-      <p:sp>
-        <p:nvSpPr>
-          <p:cNvPr id="8" name="Retângulo 7">
-            <a:extLst>
-              <a:ext uri="{FF2B5EF4-FFF2-40B4-BE49-F238E27FC236}">
-                <a16:creationId xmlns:a16="http://schemas.microsoft.com/office/drawing/2014/main" id="{5873D54B-A6A4-494F-812D-94109F493A2E}"/>
-              </a:ext>
-            </a:extLst>
-          </p:cNvPr>
-          <p:cNvSpPr>
-            <a:spLocks noGrp="1"/>
-          </p:cNvSpPr>
-          <p:nvPr/>
-        </p:nvSpPr>
-        <p:spPr>
-          <a:xfrm>
-            <a:off x="6781800" y="2428875"/>
-            <a:ext cx="2857500" cy="266700"/>
-          </a:xfrm>
-          <a:prstGeom prst="rect">
-            <a:avLst/>
-          </a:prstGeom>
-          <a:noFill/>
-          <a:ln w="0">
-            <a:noFill/>
-            <a:prstDash val="solid"/>
-          </a:ln>
-        </p:spPr>
-        <p:txBody>
-          <a:bodyPr anchor="t"/>
-          <a:lstStyle/>
-          <a:p>
-            <a:pPr algn="l">
-              <a:defRPr sz="1725" b="1">
-                <a:solidFill>
-                  <a:srgbClr val="167C80"/>
-                </a:solidFill>
-                <a:latin typeface="Aptos"/>
-                <a:ea typeface="Aptos"/>
-                <a:cs typeface="Aptos"/>
-              </a:defRPr>
-            </a:pPr>
-            <a:r>
-              <a:rPr sz="1725" b="1">
-                <a:solidFill>
-                  <a:srgbClr val="167C80"/>
-                </a:solidFill>
-                <a:latin typeface="Aptos"/>
-                <a:ea typeface="Aptos"/>
-                <a:cs typeface="Aptos"/>
-              </a:rPr>
-              <a:t>Proposta</a:t>
-            </a:r>
-          </a:p>
-        </p:txBody>
-      </p:sp>
-      <p:sp>
-        <p:nvSpPr>
-          <p:cNvPr id="9" name="Retângulo 8">
-            <a:extLst>
-              <a:ext uri="{FF2B5EF4-FFF2-40B4-BE49-F238E27FC236}">
-                <a16:creationId xmlns:a16="http://schemas.microsoft.com/office/drawing/2014/main" id="{02EC63CF-E186-432A-9328-543886C37D10}"/>
-              </a:ext>
-            </a:extLst>
-          </p:cNvPr>
-          <p:cNvSpPr>
-            <a:spLocks noGrp="1"/>
-          </p:cNvSpPr>
-          <p:nvPr/>
-        </p:nvSpPr>
-        <p:spPr>
-          <a:xfrm>
-            <a:off x="6781800" y="2905125"/>
-            <a:ext cx="228600" cy="266700"/>
-          </a:xfrm>
-          <a:prstGeom prst="rect">
-            <a:avLst/>
-          </a:prstGeom>
-          <a:noFill/>
-          <a:ln w="0">
-            <a:noFill/>
-            <a:prstDash val="solid"/>
-          </a:ln>
-        </p:spPr>
-        <p:txBody>
-          <a:bodyPr anchor="t"/>
-          <a:lstStyle/>
-          <a:p>
-            <a:pPr algn="l">
-              <a:defRPr sz="1800" b="1">
-                <a:solidFill>
-                  <a:srgbClr val="F4B942"/>
-                </a:solidFill>
-                <a:latin typeface="Aptos"/>
-                <a:ea typeface="Aptos"/>
-                <a:cs typeface="Aptos"/>
-              </a:defRPr>
-            </a:pPr>
-            <a:r>
-              <a:rPr sz="1800" b="1">
-                <a:solidFill>
-                  <a:srgbClr val="F4B942"/>
-                </a:solidFill>
-                <a:latin typeface="Aptos"/>
-                <a:ea typeface="Aptos"/>
-                <a:cs typeface="Aptos"/>
-              </a:rPr>
-              <a:t>•</a:t>
-            </a:r>
-          </a:p>
-        </p:txBody>
-      </p:sp>
-      <p:sp>
-        <p:nvSpPr>
-          <p:cNvPr id="10" name="Retângulo 9">
-            <a:extLst>
-              <a:ext uri="{FF2B5EF4-FFF2-40B4-BE49-F238E27FC236}">
-                <a16:creationId xmlns:a16="http://schemas.microsoft.com/office/drawing/2014/main" id="{DF852ED2-2640-40C7-ADB8-24AB6A999660}"/>
-              </a:ext>
-            </a:extLst>
-          </p:cNvPr>
-          <p:cNvSpPr>
-            <a:spLocks noGrp="1"/>
-          </p:cNvSpPr>
-          <p:nvPr/>
-        </p:nvSpPr>
-        <p:spPr>
-          <a:xfrm>
-            <a:off x="7048500" y="2905125"/>
-            <a:ext cx="3067050" cy="514350"/>
-          </a:xfrm>
-          <a:prstGeom prst="rect">
-            <a:avLst/>
-          </a:prstGeom>
-          <a:noFill/>
-          <a:ln w="0">
-            <a:noFill/>
-            <a:prstDash val="solid"/>
-          </a:ln>
-        </p:spPr>
-        <p:txBody>
-          <a:bodyPr anchor="t"/>
-          <a:lstStyle/>
-          <a:p>
-            <a:pPr algn="l">
-              <a:defRPr sz="1575" b="0">
-                <a:solidFill>
-                  <a:srgbClr val="14213D"/>
-                </a:solidFill>
-                <a:latin typeface="Aptos"/>
-                <a:ea typeface="Aptos"/>
-                <a:cs typeface="Aptos"/>
-              </a:defRPr>
-            </a:pPr>
-            <a:r>
-              <a:rPr sz="1575" b="0">
-                <a:solidFill>
-                  <a:srgbClr val="14213D"/>
-                </a:solidFill>
-                <a:latin typeface="Aptos"/>
-                <a:ea typeface="Aptos"/>
-                <a:cs typeface="Aptos"/>
-              </a:rPr>
-              <a:t>Fundação temática temporalmente estratificada.</a:t>
-            </a:r>
-          </a:p>
-        </p:txBody>
-      </p:sp>
-      <p:sp>
-        <p:nvSpPr>
-          <p:cNvPr id="11" name="Retângulo 10">
-            <a:extLst>
-              <a:ext uri="{FF2B5EF4-FFF2-40B4-BE49-F238E27FC236}">
-                <a16:creationId xmlns:a16="http://schemas.microsoft.com/office/drawing/2014/main" id="{E5E6ED5C-43EB-42F2-AA88-C11063747E4F}"/>
-              </a:ext>
-            </a:extLst>
-          </p:cNvPr>
-          <p:cNvSpPr>
-            <a:spLocks noGrp="1"/>
-          </p:cNvSpPr>
-          <p:nvPr/>
-        </p:nvSpPr>
-        <p:spPr>
-          <a:xfrm>
-            <a:off x="6781800" y="3476625"/>
-            <a:ext cx="228600" cy="266700"/>
-          </a:xfrm>
-          <a:prstGeom prst="rect">
-            <a:avLst/>
-          </a:prstGeom>
-          <a:noFill/>
-          <a:ln w="0">
-            <a:noFill/>
-            <a:prstDash val="solid"/>
-          </a:ln>
-        </p:spPr>
-        <p:txBody>
-          <a:bodyPr anchor="t"/>
-          <a:lstStyle/>
-          <a:p>
-            <a:pPr algn="l">
-              <a:defRPr sz="1800" b="1">
-                <a:solidFill>
-                  <a:srgbClr val="F4B942"/>
-                </a:solidFill>
-                <a:latin typeface="Aptos"/>
-                <a:ea typeface="Aptos"/>
-                <a:cs typeface="Aptos"/>
-              </a:defRPr>
-            </a:pPr>
-            <a:r>
-              <a:rPr sz="1800" b="1">
-                <a:solidFill>
-                  <a:srgbClr val="F4B942"/>
-                </a:solidFill>
-                <a:latin typeface="Aptos"/>
-                <a:ea typeface="Aptos"/>
-                <a:cs typeface="Aptos"/>
-              </a:rPr>
-              <a:t>•</a:t>
-            </a:r>
-          </a:p>
-        </p:txBody>
-      </p:sp>
-      <p:sp>
-        <p:nvSpPr>
-          <p:cNvPr id="12" name="Retângulo 11">
-            <a:extLst>
-              <a:ext uri="{FF2B5EF4-FFF2-40B4-BE49-F238E27FC236}">
-                <a16:creationId xmlns:a16="http://schemas.microsoft.com/office/drawing/2014/main" id="{60A2389A-CA13-43EA-B277-D88E6E5D0C24}"/>
-              </a:ext>
-            </a:extLst>
-          </p:cNvPr>
-          <p:cNvSpPr>
-            <a:spLocks noGrp="1"/>
-          </p:cNvSpPr>
-          <p:nvPr/>
-        </p:nvSpPr>
-        <p:spPr>
-          <a:xfrm>
-            <a:off x="7048500" y="3476625"/>
-            <a:ext cx="3067050" cy="514350"/>
-          </a:xfrm>
-          <a:prstGeom prst="rect">
-            <a:avLst/>
-          </a:prstGeom>
-          <a:noFill/>
-          <a:ln w="0">
-            <a:noFill/>
-            <a:prstDash val="solid"/>
-          </a:ln>
-        </p:spPr>
-        <p:txBody>
-          <a:bodyPr anchor="t"/>
-          <a:lstStyle/>
-          <a:p>
-            <a:pPr algn="l">
-              <a:defRPr sz="1575" b="0">
-                <a:solidFill>
-                  <a:srgbClr val="14213D"/>
-                </a:solidFill>
-                <a:latin typeface="Aptos"/>
-                <a:ea typeface="Aptos"/>
-                <a:cs typeface="Aptos"/>
-              </a:defRPr>
-            </a:pPr>
-            <a:r>
-              <a:rPr sz="1575" b="0">
-                <a:solidFill>
-                  <a:srgbClr val="14213D"/>
-                </a:solidFill>
-                <a:latin typeface="Aptos"/>
-                <a:ea typeface="Aptos"/>
-                <a:cs typeface="Aptos"/>
-              </a:rPr>
-              <a:t>Memória lexical binária WNN, versionada e auditável.</a:t>
-            </a:r>
-          </a:p>
-        </p:txBody>
-      </p:sp>
-      <p:sp>
-        <p:nvSpPr>
-          <p:cNvPr id="13" name="Retângulo 12">
-            <a:extLst>
-              <a:ext uri="{FF2B5EF4-FFF2-40B4-BE49-F238E27FC236}">
-                <a16:creationId xmlns:a16="http://schemas.microsoft.com/office/drawing/2014/main" id="{E05FD128-2D07-426F-AB99-5B9BFC3E3DD9}"/>
-              </a:ext>
-            </a:extLst>
-          </p:cNvPr>
-          <p:cNvSpPr>
-            <a:spLocks noGrp="1"/>
-          </p:cNvSpPr>
-          <p:nvPr/>
-        </p:nvSpPr>
-        <p:spPr>
-          <a:xfrm>
-            <a:off x="6781800" y="4048125"/>
-            <a:ext cx="228600" cy="266700"/>
-          </a:xfrm>
-          <a:prstGeom prst="rect">
-            <a:avLst/>
-          </a:prstGeom>
-          <a:noFill/>
-          <a:ln w="0">
-            <a:noFill/>
-            <a:prstDash val="solid"/>
-          </a:ln>
-        </p:spPr>
-        <p:txBody>
-          <a:bodyPr anchor="t"/>
-          <a:lstStyle/>
-          <a:p>
-            <a:pPr algn="l">
-              <a:defRPr sz="1800" b="1">
-                <a:solidFill>
-                  <a:srgbClr val="F4B942"/>
-                </a:solidFill>
-                <a:latin typeface="Aptos"/>
-                <a:ea typeface="Aptos"/>
-                <a:cs typeface="Aptos"/>
-              </a:defRPr>
-            </a:pPr>
-            <a:r>
-              <a:rPr sz="1800" b="1">
-                <a:solidFill>
-                  <a:srgbClr val="F4B942"/>
-                </a:solidFill>
-                <a:latin typeface="Aptos"/>
-                <a:ea typeface="Aptos"/>
-                <a:cs typeface="Aptos"/>
-              </a:rPr>
-              <a:t>•</a:t>
-            </a:r>
-          </a:p>
-        </p:txBody>
-      </p:sp>
-      <p:sp>
-        <p:nvSpPr>
-          <p:cNvPr id="14" name="Retângulo 13">
-            <a:extLst>
-              <a:ext uri="{FF2B5EF4-FFF2-40B4-BE49-F238E27FC236}">
-                <a16:creationId xmlns:a16="http://schemas.microsoft.com/office/drawing/2014/main" id="{DECF4972-5C60-4A2F-88AF-3B89A33881C8}"/>
-              </a:ext>
-            </a:extLst>
-          </p:cNvPr>
-          <p:cNvSpPr>
-            <a:spLocks noGrp="1"/>
-          </p:cNvSpPr>
-          <p:nvPr/>
-        </p:nvSpPr>
-        <p:spPr>
-          <a:xfrm>
-            <a:off x="7048500" y="4048125"/>
-            <a:ext cx="3067050" cy="514350"/>
-          </a:xfrm>
-          <a:prstGeom prst="rect">
-            <a:avLst/>
-          </a:prstGeom>
-          <a:noFill/>
-          <a:ln w="0">
-            <a:noFill/>
-            <a:prstDash val="solid"/>
-          </a:ln>
-        </p:spPr>
-        <p:txBody>
-          <a:bodyPr anchor="t"/>
-          <a:lstStyle/>
-          <a:p>
-            <a:pPr algn="l">
-              <a:defRPr sz="1575" b="0">
-                <a:solidFill>
-                  <a:srgbClr val="14213D"/>
-                </a:solidFill>
-                <a:latin typeface="Aptos"/>
-                <a:ea typeface="Aptos"/>
-                <a:cs typeface="Aptos"/>
-              </a:defRPr>
-            </a:pPr>
-            <a:r>
-              <a:rPr sz="1575" b="0">
-                <a:solidFill>
-                  <a:srgbClr val="14213D"/>
-                </a:solidFill>
-                <a:latin typeface="Aptos"/>
-                <a:ea typeface="Aptos"/>
-                <a:cs typeface="Aptos"/>
-              </a:rPr>
-              <a:t>LLM apenas para casos residuais ou inéditos.</a:t>
-            </a:r>
-          </a:p>
-        </p:txBody>
-      </p:sp>
-      <p:sp>
-        <p:nvSpPr>
-          <p:cNvPr id="15" name="Retângulo 14">
-            <a:extLst>
-              <a:ext uri="{FF2B5EF4-FFF2-40B4-BE49-F238E27FC236}">
-                <a16:creationId xmlns:a16="http://schemas.microsoft.com/office/drawing/2014/main" id="{C8B905B2-3DEF-4230-8EC0-69DD2A2D6ED4}"/>
-              </a:ext>
-            </a:extLst>
-          </p:cNvPr>
-          <p:cNvSpPr>
-            <a:spLocks noGrp="1"/>
-          </p:cNvSpPr>
-          <p:nvPr/>
-        </p:nvSpPr>
-        <p:spPr>
-          <a:xfrm>
-            <a:off x="857250" y="5191125"/>
-            <a:ext cx="9810750" cy="333375"/>
-          </a:xfrm>
-          <a:prstGeom prst="rect">
-            <a:avLst/>
-          </a:prstGeom>
-          <a:noFill/>
-          <a:ln w="0">
-            <a:noFill/>
-            <a:prstDash val="solid"/>
-          </a:ln>
-        </p:spPr>
-        <p:txBody>
-          <a:bodyPr anchor="t"/>
-          <a:lstStyle/>
-          <a:p>
-            <a:pPr algn="l">
-              <a:defRPr sz="1575" b="1">
-                <a:solidFill>
-                  <a:srgbClr val="5E6B7A"/>
-                </a:solidFill>
-                <a:latin typeface="Aptos"/>
-                <a:ea typeface="Aptos"/>
-                <a:cs typeface="Aptos"/>
-              </a:defRPr>
-            </a:pPr>
-            <a:r>
-              <a:rPr sz="1575" b="1">
-                <a:solidFill>
-                  <a:srgbClr val="5E6B7A"/>
-                </a:solidFill>
-                <a:latin typeface="Aptos"/>
-                <a:ea typeface="Aptos"/>
-                <a:cs typeface="Aptos"/>
-              </a:rPr>
-              <a:t>Não é uma reprodução da WiSARD clássica: é uma memória lexical binária inspirada em seus princípios.</a:t>
-            </a:r>
-          </a:p>
-        </p:txBody>
-      </p:sp>
-    </p:spTree>
-    <p:extLst>
-      <p:ext uri="{BB962C8B-B14F-4D97-AF65-F5344CB8AC3E}">
-        <p14:creationId xmlns:p14="http://schemas.microsoft.com/office/powerpoint/2010/main" val="73230632"/>
-      </p:ext>
-    </p:extLst>
-  </p:cSld>
-  <p:clrMapOvr>
-    <a:masterClrMapping/>
-  </p:clrMapOvr>
-</p:sld>
-</file>
-
-<file path=ppt/slides/slide11.xml><?xml version="1.0" encoding="utf-8"?>
-<p:sld xmlns:a="http://schemas.openxmlformats.org/drawingml/2006/main" xmlns:r="http://schemas.openxmlformats.org/officeDocument/2006/relationships" xmlns:p="http://schemas.openxmlformats.org/presentationml/2006/main">
-  <p:cSld>
-    <p:bg>
-      <p:bgPr>
-        <a:solidFill>
-          <a:srgbClr val="F7F8FA"/>
-        </a:solidFill>
-        <a:effectLst/>
-      </p:bgPr>
-    </p:bg>
-    <p:spTree>
-      <p:nvGrpSpPr>
-        <p:cNvPr id="1" name=""/>
-        <p:cNvGrpSpPr/>
-        <p:nvPr/>
-      </p:nvGrpSpPr>
-      <p:grpSpPr>
-        <a:xfrm>
-          <a:off x="0" y="0"/>
-          <a:ext cx="0" cy="0"/>
-          <a:chOff x="0" y="0"/>
-          <a:chExt cx="0" cy="0"/>
-        </a:xfrm>
-      </p:grpSpPr>
-      <p:sp>
-        <p:nvSpPr>
-          <p:cNvPr id="25" name="Retângulo 24">
-            <a:extLst>
-              <a:ext uri="{FF2B5EF4-FFF2-40B4-BE49-F238E27FC236}">
-                <a16:creationId xmlns:a16="http://schemas.microsoft.com/office/drawing/2014/main" id="{2A582BA2-4571-41BA-99FE-F1366B8E3E98}"/>
-              </a:ext>
-            </a:extLst>
-          </p:cNvPr>
-          <p:cNvSpPr>
-            <a:spLocks noGrp="1"/>
-          </p:cNvSpPr>
-          <p:nvPr/>
-        </p:nvSpPr>
-        <p:spPr>
-          <a:xfrm>
-            <a:off x="685800" y="514350"/>
-            <a:ext cx="609600" cy="57150"/>
-          </a:xfrm>
-          <a:prstGeom prst="rect">
-            <a:avLst/>
-          </a:prstGeom>
-          <a:solidFill>
-            <a:srgbClr val="F4B942"/>
-          </a:solidFill>
-          <a:ln w="0">
-            <a:solidFill>
-              <a:srgbClr val="F4B942"/>
-            </a:solidFill>
-            <a:prstDash val="solid"/>
-          </a:ln>
-        </p:spPr>
-        <p:txBody>
-          <a:bodyPr/>
-          <a:lstStyle/>
-          <a:p>
-            <a:endParaRPr lang="pt-PT"/>
-          </a:p>
-        </p:txBody>
-      </p:sp>
-      <p:sp>
-        <p:nvSpPr>
-          <p:cNvPr id="2" name="Retângulo 1">
-            <a:extLst>
-              <a:ext uri="{FF2B5EF4-FFF2-40B4-BE49-F238E27FC236}">
-                <a16:creationId xmlns:a16="http://schemas.microsoft.com/office/drawing/2014/main" id="{54A0C339-48B6-4ECC-BE1E-22F7B821AF03}"/>
-              </a:ext>
-            </a:extLst>
-          </p:cNvPr>
-          <p:cNvSpPr>
-            <a:spLocks noGrp="1"/>
-          </p:cNvSpPr>
-          <p:nvPr/>
-        </p:nvSpPr>
-        <p:spPr>
-          <a:xfrm>
-            <a:off x="685800" y="685800"/>
-            <a:ext cx="2857500" cy="228600"/>
-          </a:xfrm>
-          <a:prstGeom prst="rect">
-            <a:avLst/>
-          </a:prstGeom>
-          <a:noFill/>
-          <a:ln w="0">
-            <a:noFill/>
-            <a:prstDash val="solid"/>
-          </a:ln>
-        </p:spPr>
-        <p:txBody>
-          <a:bodyPr anchor="t"/>
-          <a:lstStyle/>
-          <a:p>
-            <a:pPr algn="l">
-              <a:defRPr sz="1125" b="1">
-                <a:solidFill>
-                  <a:srgbClr val="2F5D8C"/>
-                </a:solidFill>
-                <a:latin typeface="Aptos"/>
-                <a:ea typeface="Aptos"/>
-                <a:cs typeface="Aptos"/>
-              </a:defRPr>
-            </a:pPr>
-            <a:r>
-              <a:rPr sz="1125" b="1">
-                <a:solidFill>
-                  <a:srgbClr val="2F5D8C"/>
-                </a:solidFill>
-                <a:latin typeface="Aptos"/>
-                <a:ea typeface="Aptos"/>
-                <a:cs typeface="Aptos"/>
-              </a:rPr>
-              <a:t>AT | MÉTODO</a:t>
-            </a:r>
-          </a:p>
-        </p:txBody>
-      </p:sp>
-      <p:sp>
-        <p:nvSpPr>
-          <p:cNvPr id="3" name="Retângulo 2">
-            <a:extLst>
-              <a:ext uri="{FF2B5EF4-FFF2-40B4-BE49-F238E27FC236}">
-                <a16:creationId xmlns:a16="http://schemas.microsoft.com/office/drawing/2014/main" id="{FD8F55EB-00E4-4FDC-9DF2-FF15498F194F}"/>
-              </a:ext>
-            </a:extLst>
-          </p:cNvPr>
-          <p:cNvSpPr>
-            <a:spLocks noGrp="1"/>
-          </p:cNvSpPr>
-          <p:nvPr/>
-        </p:nvSpPr>
-        <p:spPr>
-          <a:xfrm>
-            <a:off x="685800" y="1009650"/>
-            <a:ext cx="10287000" cy="533400"/>
-          </a:xfrm>
-          <a:prstGeom prst="rect">
-            <a:avLst/>
-          </a:prstGeom>
-          <a:noFill/>
-          <a:ln w="0">
-            <a:noFill/>
-            <a:prstDash val="solid"/>
-          </a:ln>
-        </p:spPr>
-        <p:txBody>
-          <a:bodyPr anchor="t"/>
-          <a:lstStyle/>
-          <a:p>
-            <a:pPr algn="l">
-              <a:defRPr sz="2625" b="1">
-                <a:solidFill>
-                  <a:srgbClr val="14213D"/>
-                </a:solidFill>
-                <a:latin typeface="Aptos"/>
-                <a:ea typeface="Aptos"/>
-                <a:cs typeface="Aptos"/>
-              </a:defRPr>
-            </a:pPr>
-            <a:r>
-              <a:rPr sz="2625" b="1">
-                <a:solidFill>
-                  <a:srgbClr val="14213D"/>
-                </a:solidFill>
-                <a:latin typeface="Aptos"/>
-                <a:ea typeface="Aptos"/>
-                <a:cs typeface="Aptos"/>
-              </a:rPr>
-              <a:t>A decisão combina uma camada determinística para o recorrente e revisão contextual para o residual</a:t>
-            </a:r>
-          </a:p>
-        </p:txBody>
-      </p:sp>
-      <p:sp>
-        <p:nvSpPr>
-          <p:cNvPr id="4" name="Retângulo 3">
-            <a:extLst>
-              <a:ext uri="{FF2B5EF4-FFF2-40B4-BE49-F238E27FC236}">
-                <a16:creationId xmlns:a16="http://schemas.microsoft.com/office/drawing/2014/main" id="{AE761765-20C7-4C01-BD3B-38F388987344}"/>
-              </a:ext>
-            </a:extLst>
-          </p:cNvPr>
-          <p:cNvSpPr>
-            <a:spLocks noGrp="1"/>
-          </p:cNvSpPr>
-          <p:nvPr/>
-        </p:nvSpPr>
-        <p:spPr>
-          <a:xfrm>
-            <a:off x="10953750" y="685800"/>
-            <a:ext cx="533400" cy="266700"/>
-          </a:xfrm>
-          <a:prstGeom prst="rect">
-            <a:avLst/>
-          </a:prstGeom>
-          <a:noFill/>
-          <a:ln w="0">
-            <a:noFill/>
-            <a:prstDash val="solid"/>
-          </a:ln>
-        </p:spPr>
-        <p:txBody>
-          <a:bodyPr anchor="t"/>
-          <a:lstStyle/>
-          <a:p>
-            <a:pPr algn="r">
-              <a:defRPr sz="1200" b="1">
-                <a:solidFill>
-                  <a:srgbClr val="5E6B7A"/>
-                </a:solidFill>
-                <a:latin typeface="Aptos"/>
-                <a:ea typeface="Aptos"/>
-                <a:cs typeface="Aptos"/>
-              </a:defRPr>
-            </a:pPr>
-            <a:r>
-              <a:rPr sz="1200" b="1">
-                <a:solidFill>
-                  <a:srgbClr val="5E6B7A"/>
-                </a:solidFill>
-                <a:latin typeface="Aptos"/>
-                <a:ea typeface="Aptos"/>
-                <a:cs typeface="Aptos"/>
-              </a:rPr>
-              <a:t>10</a:t>
-            </a:r>
-          </a:p>
-        </p:txBody>
-      </p:sp>
-      <p:sp>
-        <p:nvSpPr>
-          <p:cNvPr id="5" name="Retângulo: Cantos Arredondados 4">
-            <a:extLst>
-              <a:ext uri="{FF2B5EF4-FFF2-40B4-BE49-F238E27FC236}">
-                <a16:creationId xmlns:a16="http://schemas.microsoft.com/office/drawing/2014/main" id="{0E483686-2CC7-4B06-8DC5-96CA0E9FCE3C}"/>
-              </a:ext>
-            </a:extLst>
-          </p:cNvPr>
-          <p:cNvSpPr>
-            <a:spLocks noGrp="1"/>
-          </p:cNvSpPr>
-          <p:nvPr/>
-        </p:nvSpPr>
-        <p:spPr>
-          <a:xfrm>
-            <a:off x="609600" y="2667000"/>
-            <a:ext cx="2333625" cy="1695450"/>
-          </a:xfrm>
-          <a:prstGeom prst="roundRect">
-            <a:avLst>
-              <a:gd name="adj" fmla="val 6742"/>
-            </a:avLst>
-          </a:prstGeom>
-          <a:solidFill>
-            <a:srgbClr val="FFFFFF"/>
-          </a:solidFill>
-          <a:ln w="9525">
-            <a:solidFill>
-              <a:srgbClr val="D9DEE5"/>
-            </a:solidFill>
-            <a:prstDash val="solid"/>
-          </a:ln>
-        </p:spPr>
-        <p:txBody>
-          <a:bodyPr/>
-          <a:lstStyle/>
-          <a:p>
-            <a:endParaRPr lang="pt-PT"/>
-          </a:p>
-        </p:txBody>
-      </p:sp>
-      <p:sp>
-        <p:nvSpPr>
-          <p:cNvPr id="6" name="Retângulo 5">
-            <a:extLst>
-              <a:ext uri="{FF2B5EF4-FFF2-40B4-BE49-F238E27FC236}">
-                <a16:creationId xmlns:a16="http://schemas.microsoft.com/office/drawing/2014/main" id="{C2471B3E-1762-4CC4-B1B6-D88A220ADB7B}"/>
-              </a:ext>
-            </a:extLst>
-          </p:cNvPr>
-          <p:cNvSpPr>
-            <a:spLocks noGrp="1"/>
-          </p:cNvSpPr>
-          <p:nvPr/>
-        </p:nvSpPr>
-        <p:spPr>
-          <a:xfrm>
-            <a:off x="781050" y="2933700"/>
-            <a:ext cx="1952625" cy="228600"/>
-          </a:xfrm>
-          <a:prstGeom prst="rect">
-            <a:avLst/>
-          </a:prstGeom>
-          <a:noFill/>
-          <a:ln w="0">
-            <a:noFill/>
-            <a:prstDash val="solid"/>
-          </a:ln>
-        </p:spPr>
-        <p:txBody>
-          <a:bodyPr anchor="t"/>
-          <a:lstStyle/>
-          <a:p>
-            <a:pPr algn="l">
-              <a:defRPr sz="1350" b="1">
-                <a:solidFill>
-                  <a:srgbClr val="2F5D8C"/>
-                </a:solidFill>
-                <a:latin typeface="Aptos"/>
-                <a:ea typeface="Aptos"/>
-                <a:cs typeface="Aptos"/>
-              </a:defRPr>
-            </a:pPr>
-            <a:r>
-              <a:rPr sz="1350" b="1">
-                <a:solidFill>
-                  <a:srgbClr val="2F5D8C"/>
-                </a:solidFill>
-                <a:latin typeface="Aptos"/>
-                <a:ea typeface="Aptos"/>
-                <a:cs typeface="Aptos"/>
-              </a:rPr>
-              <a:t>10%</a:t>
-            </a:r>
-          </a:p>
-        </p:txBody>
-      </p:sp>
-      <p:sp>
-        <p:nvSpPr>
-          <p:cNvPr id="7" name="Retângulo 6">
-            <a:extLst>
-              <a:ext uri="{FF2B5EF4-FFF2-40B4-BE49-F238E27FC236}">
-                <a16:creationId xmlns:a16="http://schemas.microsoft.com/office/drawing/2014/main" id="{398A83D9-EBE8-4DA1-AB55-962CBE56ED56}"/>
-              </a:ext>
-            </a:extLst>
-          </p:cNvPr>
-          <p:cNvSpPr>
-            <a:spLocks noGrp="1"/>
-          </p:cNvSpPr>
-          <p:nvPr/>
-        </p:nvSpPr>
-        <p:spPr>
-          <a:xfrm>
-            <a:off x="781050" y="3305175"/>
-            <a:ext cx="1952625" cy="400050"/>
-          </a:xfrm>
-          <a:prstGeom prst="rect">
-            <a:avLst/>
-          </a:prstGeom>
-          <a:noFill/>
-          <a:ln w="0">
-            <a:noFill/>
-            <a:prstDash val="solid"/>
-          </a:ln>
-        </p:spPr>
-        <p:txBody>
-          <a:bodyPr anchor="t"/>
-          <a:lstStyle/>
-          <a:p>
-            <a:pPr algn="l">
-              <a:defRPr sz="1725" b="1">
-                <a:solidFill>
-                  <a:srgbClr val="14213D"/>
-                </a:solidFill>
-                <a:latin typeface="Aptos"/>
-                <a:ea typeface="Aptos"/>
-                <a:cs typeface="Aptos"/>
-              </a:defRPr>
-            </a:pPr>
-            <a:r>
-              <a:rPr sz="1725" b="1">
-                <a:solidFill>
-                  <a:srgbClr val="14213D"/>
-                </a:solidFill>
-                <a:latin typeface="Aptos"/>
-                <a:ea typeface="Aptos"/>
-                <a:cs typeface="Aptos"/>
-              </a:rPr>
-              <a:t>Fundação temática</a:t>
-            </a:r>
-          </a:p>
-        </p:txBody>
-      </p:sp>
-      <p:sp>
-        <p:nvSpPr>
-          <p:cNvPr id="8" name="Retângulo 7">
-            <a:extLst>
-              <a:ext uri="{FF2B5EF4-FFF2-40B4-BE49-F238E27FC236}">
-                <a16:creationId xmlns:a16="http://schemas.microsoft.com/office/drawing/2014/main" id="{07FB98D4-7690-47D3-9BA5-7B23461890E0}"/>
-              </a:ext>
-            </a:extLst>
-          </p:cNvPr>
-          <p:cNvSpPr>
-            <a:spLocks noGrp="1"/>
-          </p:cNvSpPr>
-          <p:nvPr/>
-        </p:nvSpPr>
-        <p:spPr>
-          <a:xfrm>
-            <a:off x="781050" y="3886200"/>
-            <a:ext cx="1952625" cy="381000"/>
-          </a:xfrm>
-          <a:prstGeom prst="rect">
-            <a:avLst/>
-          </a:prstGeom>
-          <a:noFill/>
-          <a:ln w="0">
-            <a:noFill/>
-            <a:prstDash val="solid"/>
-          </a:ln>
-        </p:spPr>
-        <p:txBody>
-          <a:bodyPr anchor="t"/>
-          <a:lstStyle/>
-          <a:p>
-            <a:pPr algn="l">
-              <a:defRPr sz="1200" b="0">
-                <a:solidFill>
-                  <a:srgbClr val="5E6B7A"/>
-                </a:solidFill>
-                <a:latin typeface="Aptos"/>
-                <a:ea typeface="Aptos"/>
-                <a:cs typeface="Aptos"/>
-              </a:defRPr>
-            </a:pPr>
-            <a:r>
-              <a:rPr sz="1200" b="0">
-                <a:solidFill>
-                  <a:srgbClr val="5E6B7A"/>
-                </a:solidFill>
-                <a:latin typeface="Aptos"/>
-                <a:ea typeface="Aptos"/>
-                <a:cs typeface="Aptos"/>
-              </a:rPr>
-              <a:t>crimes canônicos + marcadores</a:t>
-            </a:r>
-          </a:p>
-        </p:txBody>
-      </p:sp>
-      <p:sp>
-        <p:nvSpPr>
-          <p:cNvPr id="9" name="Seta: para a Direita 8">
-            <a:extLst>
-              <a:ext uri="{FF2B5EF4-FFF2-40B4-BE49-F238E27FC236}">
-                <a16:creationId xmlns:a16="http://schemas.microsoft.com/office/drawing/2014/main" id="{9F9FFEC9-B7CE-48D3-B75E-BB64CB78AA69}"/>
-              </a:ext>
-            </a:extLst>
-          </p:cNvPr>
-          <p:cNvSpPr>
-            <a:spLocks noGrp="1"/>
-          </p:cNvSpPr>
-          <p:nvPr/>
-        </p:nvSpPr>
-        <p:spPr>
-          <a:xfrm>
-            <a:off x="2971800" y="3333750"/>
-            <a:ext cx="371475" cy="238125"/>
-          </a:xfrm>
-          <a:prstGeom prst="rightArrow">
-            <a:avLst/>
-          </a:prstGeom>
-          <a:solidFill>
-            <a:srgbClr val="F4B942"/>
-          </a:solidFill>
-          <a:ln w="0">
-            <a:solidFill>
-              <a:srgbClr val="F4B942"/>
-            </a:solidFill>
-            <a:prstDash val="solid"/>
-          </a:ln>
-        </p:spPr>
-        <p:txBody>
-          <a:bodyPr/>
-          <a:lstStyle/>
-          <a:p>
-            <a:endParaRPr lang="pt-PT"/>
-          </a:p>
-        </p:txBody>
-      </p:sp>
-      <p:sp>
-        <p:nvSpPr>
-          <p:cNvPr id="10" name="Retângulo: Cantos Arredondados 9">
-            <a:extLst>
-              <a:ext uri="{FF2B5EF4-FFF2-40B4-BE49-F238E27FC236}">
-                <a16:creationId xmlns:a16="http://schemas.microsoft.com/office/drawing/2014/main" id="{83FDA659-07AF-4824-A335-36142CEC4A78}"/>
-              </a:ext>
-            </a:extLst>
-          </p:cNvPr>
-          <p:cNvSpPr>
-            <a:spLocks noGrp="1"/>
-          </p:cNvSpPr>
-          <p:nvPr/>
-        </p:nvSpPr>
-        <p:spPr>
-          <a:xfrm>
-            <a:off x="3419475" y="2667000"/>
-            <a:ext cx="2333625" cy="1695450"/>
-          </a:xfrm>
-          <a:prstGeom prst="roundRect">
-            <a:avLst>
-              <a:gd name="adj" fmla="val 6742"/>
-            </a:avLst>
-          </a:prstGeom>
-          <a:solidFill>
-            <a:srgbClr val="FFFFFF"/>
-          </a:solidFill>
-          <a:ln w="9525">
-            <a:solidFill>
-              <a:srgbClr val="D9DEE5"/>
-            </a:solidFill>
-            <a:prstDash val="solid"/>
-          </a:ln>
-        </p:spPr>
-        <p:txBody>
-          <a:bodyPr/>
-          <a:lstStyle/>
-          <a:p>
-            <a:endParaRPr lang="pt-PT"/>
-          </a:p>
-        </p:txBody>
-      </p:sp>
-      <p:sp>
-        <p:nvSpPr>
-          <p:cNvPr id="11" name="Retângulo 10">
-            <a:extLst>
-              <a:ext uri="{FF2B5EF4-FFF2-40B4-BE49-F238E27FC236}">
-                <a16:creationId xmlns:a16="http://schemas.microsoft.com/office/drawing/2014/main" id="{E3613E7F-0148-4605-BE31-EC050F2B0E25}"/>
-              </a:ext>
-            </a:extLst>
-          </p:cNvPr>
-          <p:cNvSpPr>
-            <a:spLocks noGrp="1"/>
-          </p:cNvSpPr>
-          <p:nvPr/>
-        </p:nvSpPr>
-        <p:spPr>
-          <a:xfrm>
-            <a:off x="3590925" y="2933700"/>
-            <a:ext cx="1952625" cy="228600"/>
-          </a:xfrm>
-          <a:prstGeom prst="rect">
-            <a:avLst/>
-          </a:prstGeom>
-          <a:noFill/>
-          <a:ln w="0">
-            <a:noFill/>
-            <a:prstDash val="solid"/>
-          </a:ln>
-        </p:spPr>
-        <p:txBody>
-          <a:bodyPr anchor="t"/>
-          <a:lstStyle/>
-          <a:p>
-            <a:pPr algn="l">
-              <a:defRPr sz="1350" b="1">
-                <a:solidFill>
-                  <a:srgbClr val="2F5D8C"/>
-                </a:solidFill>
-                <a:latin typeface="Aptos"/>
-                <a:ea typeface="Aptos"/>
-                <a:cs typeface="Aptos"/>
-              </a:defRPr>
-            </a:pPr>
-            <a:r>
-              <a:rPr sz="1350" b="1">
-                <a:solidFill>
-                  <a:srgbClr val="2F5D8C"/>
-                </a:solidFill>
-                <a:latin typeface="Aptos"/>
-                <a:ea typeface="Aptos"/>
-                <a:cs typeface="Aptos"/>
-              </a:rPr>
-              <a:t>90%</a:t>
-            </a:r>
-          </a:p>
-        </p:txBody>
-      </p:sp>
-      <p:sp>
-        <p:nvSpPr>
-          <p:cNvPr id="12" name="Retângulo 11">
-            <a:extLst>
-              <a:ext uri="{FF2B5EF4-FFF2-40B4-BE49-F238E27FC236}">
-                <a16:creationId xmlns:a16="http://schemas.microsoft.com/office/drawing/2014/main" id="{FC0937B7-F3FB-4B92-8EB4-A7BA790E8381}"/>
-              </a:ext>
-            </a:extLst>
-          </p:cNvPr>
-          <p:cNvSpPr>
-            <a:spLocks noGrp="1"/>
-          </p:cNvSpPr>
-          <p:nvPr/>
-        </p:nvSpPr>
-        <p:spPr>
-          <a:xfrm>
-            <a:off x="3590925" y="3305175"/>
-            <a:ext cx="1952625" cy="400050"/>
-          </a:xfrm>
-          <a:prstGeom prst="rect">
-            <a:avLst/>
-          </a:prstGeom>
-          <a:noFill/>
-          <a:ln w="0">
-            <a:noFill/>
-            <a:prstDash val="solid"/>
-          </a:ln>
-        </p:spPr>
-        <p:txBody>
-          <a:bodyPr anchor="t"/>
-          <a:lstStyle/>
-          <a:p>
-            <a:pPr algn="l">
-              <a:defRPr sz="1725" b="1">
-                <a:solidFill>
-                  <a:srgbClr val="14213D"/>
-                </a:solidFill>
-                <a:latin typeface="Aptos"/>
-                <a:ea typeface="Aptos"/>
-                <a:cs typeface="Aptos"/>
-              </a:defRPr>
-            </a:pPr>
-            <a:r>
-              <a:rPr sz="1725" b="1">
-                <a:solidFill>
-                  <a:srgbClr val="14213D"/>
-                </a:solidFill>
-                <a:latin typeface="Aptos"/>
-                <a:ea typeface="Aptos"/>
-                <a:cs typeface="Aptos"/>
-              </a:rPr>
-              <a:t>Reserva incremental</a:t>
-            </a:r>
-          </a:p>
-        </p:txBody>
-      </p:sp>
-      <p:sp>
-        <p:nvSpPr>
-          <p:cNvPr id="13" name="Retângulo 12">
-            <a:extLst>
-              <a:ext uri="{FF2B5EF4-FFF2-40B4-BE49-F238E27FC236}">
-                <a16:creationId xmlns:a16="http://schemas.microsoft.com/office/drawing/2014/main" id="{B736478E-2230-4191-8389-A6C9FE7663C3}"/>
-              </a:ext>
-            </a:extLst>
-          </p:cNvPr>
-          <p:cNvSpPr>
-            <a:spLocks noGrp="1"/>
-          </p:cNvSpPr>
-          <p:nvPr/>
-        </p:nvSpPr>
-        <p:spPr>
-          <a:xfrm>
-            <a:off x="3590925" y="3886200"/>
-            <a:ext cx="1952625" cy="381000"/>
-          </a:xfrm>
-          <a:prstGeom prst="rect">
-            <a:avLst/>
-          </a:prstGeom>
-          <a:noFill/>
-          <a:ln w="0">
-            <a:noFill/>
-            <a:prstDash val="solid"/>
-          </a:ln>
-        </p:spPr>
-        <p:txBody>
-          <a:bodyPr anchor="t"/>
-          <a:lstStyle/>
-          <a:p>
-            <a:pPr algn="l">
-              <a:defRPr sz="1200" b="0">
-                <a:solidFill>
-                  <a:srgbClr val="5E6B7A"/>
-                </a:solidFill>
-                <a:latin typeface="Aptos"/>
-                <a:ea typeface="Aptos"/>
-                <a:cs typeface="Aptos"/>
-              </a:defRPr>
-            </a:pPr>
-            <a:r>
-              <a:rPr sz="1200" b="0">
-                <a:solidFill>
-                  <a:srgbClr val="5E6B7A"/>
-                </a:solidFill>
-                <a:latin typeface="Aptos"/>
-                <a:ea typeface="Aptos"/>
-                <a:cs typeface="Aptos"/>
-              </a:rPr>
-              <a:t>lotes de notícias</a:t>
-            </a:r>
-          </a:p>
-        </p:txBody>
-      </p:sp>
-      <p:sp>
-        <p:nvSpPr>
-          <p:cNvPr id="14" name="Seta: para a Direita 13">
-            <a:extLst>
-              <a:ext uri="{FF2B5EF4-FFF2-40B4-BE49-F238E27FC236}">
-                <a16:creationId xmlns:a16="http://schemas.microsoft.com/office/drawing/2014/main" id="{33D5FAB8-1A72-41D4-99D1-3DEE57A2BAC6}"/>
-              </a:ext>
-            </a:extLst>
-          </p:cNvPr>
-          <p:cNvSpPr>
-            <a:spLocks noGrp="1"/>
-          </p:cNvSpPr>
-          <p:nvPr/>
-        </p:nvSpPr>
-        <p:spPr>
-          <a:xfrm>
-            <a:off x="5781675" y="3333750"/>
-            <a:ext cx="371475" cy="238125"/>
-          </a:xfrm>
-          <a:prstGeom prst="rightArrow">
-            <a:avLst/>
-          </a:prstGeom>
-          <a:solidFill>
-            <a:srgbClr val="F4B942"/>
-          </a:solidFill>
-          <a:ln w="0">
-            <a:solidFill>
-              <a:srgbClr val="F4B942"/>
-            </a:solidFill>
-            <a:prstDash val="solid"/>
-          </a:ln>
-        </p:spPr>
-        <p:txBody>
-          <a:bodyPr/>
-          <a:lstStyle/>
-          <a:p>
-            <a:endParaRPr lang="pt-PT"/>
-          </a:p>
-        </p:txBody>
-      </p:sp>
-      <p:sp>
-        <p:nvSpPr>
-          <p:cNvPr id="15" name="Retângulo: Cantos Arredondados 14">
-            <a:extLst>
-              <a:ext uri="{FF2B5EF4-FFF2-40B4-BE49-F238E27FC236}">
-                <a16:creationId xmlns:a16="http://schemas.microsoft.com/office/drawing/2014/main" id="{DCE81FB5-A898-4B26-8D6E-C66B80342C36}"/>
-              </a:ext>
-            </a:extLst>
-          </p:cNvPr>
-          <p:cNvSpPr>
-            <a:spLocks noGrp="1"/>
-          </p:cNvSpPr>
-          <p:nvPr/>
-        </p:nvSpPr>
-        <p:spPr>
-          <a:xfrm>
-            <a:off x="6229350" y="2667000"/>
-            <a:ext cx="2333625" cy="1695450"/>
-          </a:xfrm>
-          <a:prstGeom prst="roundRect">
-            <a:avLst>
-              <a:gd name="adj" fmla="val 6742"/>
-            </a:avLst>
-          </a:prstGeom>
-          <a:solidFill>
-            <a:srgbClr val="EAF5F2"/>
-          </a:solidFill>
-          <a:ln w="9525">
-            <a:solidFill>
-              <a:srgbClr val="BDE0D8"/>
-            </a:solidFill>
-            <a:prstDash val="solid"/>
-          </a:ln>
-        </p:spPr>
-        <p:txBody>
-          <a:bodyPr/>
-          <a:lstStyle/>
-          <a:p>
-            <a:endParaRPr lang="pt-PT"/>
-          </a:p>
-        </p:txBody>
-      </p:sp>
-      <p:sp>
-        <p:nvSpPr>
-          <p:cNvPr id="16" name="Retângulo 15">
-            <a:extLst>
-              <a:ext uri="{FF2B5EF4-FFF2-40B4-BE49-F238E27FC236}">
-                <a16:creationId xmlns:a16="http://schemas.microsoft.com/office/drawing/2014/main" id="{17D2F5E6-FD7B-413D-84B2-BD3CDC73B844}"/>
-              </a:ext>
-            </a:extLst>
-          </p:cNvPr>
-          <p:cNvSpPr>
-            <a:spLocks noGrp="1"/>
-          </p:cNvSpPr>
-          <p:nvPr/>
-        </p:nvSpPr>
-        <p:spPr>
-          <a:xfrm>
-            <a:off x="6400800" y="2933700"/>
-            <a:ext cx="1952625" cy="228600"/>
-          </a:xfrm>
-          <a:prstGeom prst="rect">
-            <a:avLst/>
-          </a:prstGeom>
-          <a:noFill/>
-          <a:ln w="0">
-            <a:noFill/>
-            <a:prstDash val="solid"/>
-          </a:ln>
-        </p:spPr>
-        <p:txBody>
-          <a:bodyPr anchor="t"/>
-          <a:lstStyle/>
-          <a:p>
-            <a:pPr algn="l">
-              <a:defRPr sz="1350" b="1">
-                <a:solidFill>
-                  <a:srgbClr val="2F5D8C"/>
-                </a:solidFill>
-                <a:latin typeface="Aptos"/>
-                <a:ea typeface="Aptos"/>
-                <a:cs typeface="Aptos"/>
-              </a:defRPr>
-            </a:pPr>
-            <a:r>
-              <a:rPr sz="1350" b="1">
-                <a:solidFill>
-                  <a:srgbClr val="2F5D8C"/>
-                </a:solidFill>
-                <a:latin typeface="Aptos"/>
-                <a:ea typeface="Aptos"/>
-                <a:cs typeface="Aptos"/>
-              </a:rPr>
-              <a:t>WNN</a:t>
-            </a:r>
-          </a:p>
-        </p:txBody>
-      </p:sp>
-      <p:sp>
-        <p:nvSpPr>
-          <p:cNvPr id="17" name="Retângulo 16">
-            <a:extLst>
-              <a:ext uri="{FF2B5EF4-FFF2-40B4-BE49-F238E27FC236}">
-                <a16:creationId xmlns:a16="http://schemas.microsoft.com/office/drawing/2014/main" id="{48ADF405-2FAF-47D2-818E-B0C42D1DD6F1}"/>
-              </a:ext>
-            </a:extLst>
-          </p:cNvPr>
-          <p:cNvSpPr>
-            <a:spLocks noGrp="1"/>
-          </p:cNvSpPr>
-          <p:nvPr/>
-        </p:nvSpPr>
-        <p:spPr>
-          <a:xfrm>
-            <a:off x="6400800" y="3305175"/>
-            <a:ext cx="1952625" cy="400050"/>
-          </a:xfrm>
-          <a:prstGeom prst="rect">
-            <a:avLst/>
-          </a:prstGeom>
-          <a:noFill/>
-          <a:ln w="0">
-            <a:noFill/>
-            <a:prstDash val="solid"/>
-          </a:ln>
-        </p:spPr>
-        <p:txBody>
-          <a:bodyPr anchor="t"/>
-          <a:lstStyle/>
-          <a:p>
-            <a:pPr algn="l">
-              <a:defRPr sz="1725" b="1">
-                <a:solidFill>
-                  <a:srgbClr val="14213D"/>
-                </a:solidFill>
-                <a:latin typeface="Aptos"/>
-                <a:ea typeface="Aptos"/>
-                <a:cs typeface="Aptos"/>
-              </a:defRPr>
-            </a:pPr>
-            <a:r>
-              <a:rPr sz="1725" b="1">
-                <a:solidFill>
-                  <a:srgbClr val="14213D"/>
-                </a:solidFill>
-                <a:latin typeface="Aptos"/>
-                <a:ea typeface="Aptos"/>
-                <a:cs typeface="Aptos"/>
-              </a:rPr>
-              <a:t>Memória lexical</a:t>
-            </a:r>
-          </a:p>
-        </p:txBody>
-      </p:sp>
-      <p:sp>
-        <p:nvSpPr>
-          <p:cNvPr id="18" name="Retângulo 17">
-            <a:extLst>
-              <a:ext uri="{FF2B5EF4-FFF2-40B4-BE49-F238E27FC236}">
-                <a16:creationId xmlns:a16="http://schemas.microsoft.com/office/drawing/2014/main" id="{F321D4FF-DCBF-48E7-8B91-5C88D999FB4F}"/>
-              </a:ext>
-            </a:extLst>
-          </p:cNvPr>
-          <p:cNvSpPr>
-            <a:spLocks noGrp="1"/>
-          </p:cNvSpPr>
-          <p:nvPr/>
-        </p:nvSpPr>
-        <p:spPr>
-          <a:xfrm>
-            <a:off x="6400800" y="3886200"/>
-            <a:ext cx="1952625" cy="381000"/>
-          </a:xfrm>
-          <a:prstGeom prst="rect">
-            <a:avLst/>
-          </a:prstGeom>
-          <a:noFill/>
-          <a:ln w="0">
-            <a:noFill/>
-            <a:prstDash val="solid"/>
-          </a:ln>
-        </p:spPr>
-        <p:txBody>
-          <a:bodyPr anchor="t"/>
-          <a:lstStyle/>
-          <a:p>
-            <a:pPr algn="l">
-              <a:defRPr sz="1200" b="0">
-                <a:solidFill>
-                  <a:srgbClr val="5E6B7A"/>
-                </a:solidFill>
-                <a:latin typeface="Aptos"/>
-                <a:ea typeface="Aptos"/>
-                <a:cs typeface="Aptos"/>
-              </a:defRPr>
-            </a:pPr>
-            <a:r>
-              <a:rPr sz="1200" b="0">
-                <a:solidFill>
-                  <a:srgbClr val="5E6B7A"/>
-                </a:solidFill>
-                <a:latin typeface="Aptos"/>
-                <a:ea typeface="Aptos"/>
-                <a:cs typeface="Aptos"/>
-              </a:rPr>
-              <a:t>cobertura, confiança e margem</a:t>
-            </a:r>
-          </a:p>
-        </p:txBody>
-      </p:sp>
-      <p:sp>
-        <p:nvSpPr>
-          <p:cNvPr id="19" name="Seta: para a Direita 18">
-            <a:extLst>
-              <a:ext uri="{FF2B5EF4-FFF2-40B4-BE49-F238E27FC236}">
-                <a16:creationId xmlns:a16="http://schemas.microsoft.com/office/drawing/2014/main" id="{6D8E37CA-3E6C-4F50-8364-226ECF8F3620}"/>
-              </a:ext>
-            </a:extLst>
-          </p:cNvPr>
-          <p:cNvSpPr>
-            <a:spLocks noGrp="1"/>
-          </p:cNvSpPr>
-          <p:nvPr/>
-        </p:nvSpPr>
-        <p:spPr>
-          <a:xfrm>
-            <a:off x="8591550" y="3333750"/>
-            <a:ext cx="371475" cy="238125"/>
-          </a:xfrm>
-          <a:prstGeom prst="rightArrow">
-            <a:avLst/>
-          </a:prstGeom>
-          <a:solidFill>
-            <a:srgbClr val="F4B942"/>
-          </a:solidFill>
-          <a:ln w="0">
-            <a:solidFill>
-              <a:srgbClr val="F4B942"/>
-            </a:solidFill>
-            <a:prstDash val="solid"/>
-          </a:ln>
-        </p:spPr>
-        <p:txBody>
-          <a:bodyPr/>
-          <a:lstStyle/>
-          <a:p>
-            <a:endParaRPr lang="pt-PT"/>
-          </a:p>
-        </p:txBody>
-      </p:sp>
-      <p:sp>
-        <p:nvSpPr>
-          <p:cNvPr id="20" name="Retângulo: Cantos Arredondados 19">
-            <a:extLst>
-              <a:ext uri="{FF2B5EF4-FFF2-40B4-BE49-F238E27FC236}">
-                <a16:creationId xmlns:a16="http://schemas.microsoft.com/office/drawing/2014/main" id="{ADF17BF3-83DC-405B-9425-F3B279E1699B}"/>
-              </a:ext>
-            </a:extLst>
-          </p:cNvPr>
-          <p:cNvSpPr>
-            <a:spLocks noGrp="1"/>
-          </p:cNvSpPr>
-          <p:nvPr/>
-        </p:nvSpPr>
-        <p:spPr>
-          <a:xfrm>
-            <a:off x="9039225" y="2667000"/>
-            <a:ext cx="2333625" cy="1695450"/>
-          </a:xfrm>
-          <a:prstGeom prst="roundRect">
-            <a:avLst>
-              <a:gd name="adj" fmla="val 6742"/>
-            </a:avLst>
-          </a:prstGeom>
-          <a:solidFill>
-            <a:srgbClr val="FFFFFF"/>
-          </a:solidFill>
-          <a:ln w="9525">
-            <a:solidFill>
-              <a:srgbClr val="D9DEE5"/>
-            </a:solidFill>
-            <a:prstDash val="solid"/>
-          </a:ln>
-        </p:spPr>
-        <p:txBody>
-          <a:bodyPr/>
-          <a:lstStyle/>
-          <a:p>
-            <a:endParaRPr lang="pt-PT"/>
-          </a:p>
-        </p:txBody>
-      </p:sp>
-      <p:sp>
-        <p:nvSpPr>
-          <p:cNvPr id="21" name="Retângulo 20">
-            <a:extLst>
-              <a:ext uri="{FF2B5EF4-FFF2-40B4-BE49-F238E27FC236}">
-                <a16:creationId xmlns:a16="http://schemas.microsoft.com/office/drawing/2014/main" id="{80ECBFDB-622B-4837-BC4C-F9B3C4001FB5}"/>
-              </a:ext>
-            </a:extLst>
-          </p:cNvPr>
-          <p:cNvSpPr>
-            <a:spLocks noGrp="1"/>
-          </p:cNvSpPr>
-          <p:nvPr/>
-        </p:nvSpPr>
-        <p:spPr>
-          <a:xfrm>
-            <a:off x="9210675" y="2933700"/>
-            <a:ext cx="1952625" cy="228600"/>
-          </a:xfrm>
-          <a:prstGeom prst="rect">
-            <a:avLst/>
-          </a:prstGeom>
-          <a:noFill/>
-          <a:ln w="0">
-            <a:noFill/>
-            <a:prstDash val="solid"/>
-          </a:ln>
-        </p:spPr>
-        <p:txBody>
-          <a:bodyPr anchor="t"/>
-          <a:lstStyle/>
-          <a:p>
-            <a:pPr algn="l">
-              <a:defRPr sz="1350" b="1">
-                <a:solidFill>
-                  <a:srgbClr val="D96C4B"/>
-                </a:solidFill>
-                <a:latin typeface="Aptos"/>
-                <a:ea typeface="Aptos"/>
-                <a:cs typeface="Aptos"/>
-              </a:defRPr>
-            </a:pPr>
-            <a:r>
-              <a:rPr sz="1350" b="1">
-                <a:solidFill>
-                  <a:srgbClr val="D96C4B"/>
-                </a:solidFill>
-                <a:latin typeface="Aptos"/>
-                <a:ea typeface="Aptos"/>
-                <a:cs typeface="Aptos"/>
-              </a:rPr>
-              <a:t>LLM</a:t>
-            </a:r>
-          </a:p>
-        </p:txBody>
-      </p:sp>
-      <p:sp>
-        <p:nvSpPr>
-          <p:cNvPr id="22" name="Retângulo 21">
-            <a:extLst>
-              <a:ext uri="{FF2B5EF4-FFF2-40B4-BE49-F238E27FC236}">
-                <a16:creationId xmlns:a16="http://schemas.microsoft.com/office/drawing/2014/main" id="{9BF48D9D-735F-4844-A546-39C463625DDB}"/>
-              </a:ext>
-            </a:extLst>
-          </p:cNvPr>
-          <p:cNvSpPr>
-            <a:spLocks noGrp="1"/>
-          </p:cNvSpPr>
-          <p:nvPr/>
-        </p:nvSpPr>
-        <p:spPr>
-          <a:xfrm>
-            <a:off x="9210675" y="3305175"/>
-            <a:ext cx="1952625" cy="400050"/>
-          </a:xfrm>
-          <a:prstGeom prst="rect">
-            <a:avLst/>
-          </a:prstGeom>
-          <a:noFill/>
-          <a:ln w="0">
-            <a:noFill/>
-            <a:prstDash val="solid"/>
-          </a:ln>
-        </p:spPr>
-        <p:txBody>
-          <a:bodyPr anchor="t"/>
-          <a:lstStyle/>
-          <a:p>
-            <a:pPr algn="l">
-              <a:defRPr sz="1725" b="1">
-                <a:solidFill>
-                  <a:srgbClr val="14213D"/>
-                </a:solidFill>
-                <a:latin typeface="Aptos"/>
-                <a:ea typeface="Aptos"/>
-                <a:cs typeface="Aptos"/>
-              </a:defRPr>
-            </a:pPr>
-            <a:r>
-              <a:rPr sz="1725" b="1">
-                <a:solidFill>
-                  <a:srgbClr val="14213D"/>
-                </a:solidFill>
-                <a:latin typeface="Aptos"/>
-                <a:ea typeface="Aptos"/>
-                <a:cs typeface="Aptos"/>
-              </a:rPr>
-              <a:t>Revisão residual</a:t>
-            </a:r>
-          </a:p>
-        </p:txBody>
-      </p:sp>
-      <p:sp>
-        <p:nvSpPr>
-          <p:cNvPr id="23" name="Retângulo 22">
-            <a:extLst>
-              <a:ext uri="{FF2B5EF4-FFF2-40B4-BE49-F238E27FC236}">
-                <a16:creationId xmlns:a16="http://schemas.microsoft.com/office/drawing/2014/main" id="{FB3FA12D-F701-4432-A02B-89A07D82E241}"/>
-              </a:ext>
-            </a:extLst>
-          </p:cNvPr>
-          <p:cNvSpPr>
-            <a:spLocks noGrp="1"/>
-          </p:cNvSpPr>
-          <p:nvPr/>
-        </p:nvSpPr>
-        <p:spPr>
-          <a:xfrm>
-            <a:off x="9210675" y="3886200"/>
-            <a:ext cx="1952625" cy="381000"/>
-          </a:xfrm>
-          <a:prstGeom prst="rect">
-            <a:avLst/>
-          </a:prstGeom>
-          <a:noFill/>
-          <a:ln w="0">
-            <a:noFill/>
-            <a:prstDash val="solid"/>
-          </a:ln>
-        </p:spPr>
-        <p:txBody>
-          <a:bodyPr anchor="t"/>
-          <a:lstStyle/>
-          <a:p>
-            <a:pPr algn="l">
-              <a:defRPr sz="1200" b="0">
-                <a:solidFill>
-                  <a:srgbClr val="5E6B7A"/>
-                </a:solidFill>
-                <a:latin typeface="Aptos"/>
-                <a:ea typeface="Aptos"/>
-                <a:cs typeface="Aptos"/>
-              </a:defRPr>
-            </a:pPr>
-            <a:r>
-              <a:rPr sz="1200" b="0">
-                <a:solidFill>
-                  <a:srgbClr val="5E6B7A"/>
-                </a:solidFill>
-                <a:latin typeface="Aptos"/>
-                <a:ea typeface="Aptos"/>
-                <a:cs typeface="Aptos"/>
-              </a:rPr>
-              <a:t>ambiguidade, baixa evidência ou novidade</a:t>
-            </a:r>
-          </a:p>
-        </p:txBody>
-      </p:sp>
-      <p:sp>
-        <p:nvSpPr>
-          <p:cNvPr id="24" name="Retângulo 23">
-            <a:extLst>
-              <a:ext uri="{FF2B5EF4-FFF2-40B4-BE49-F238E27FC236}">
-                <a16:creationId xmlns:a16="http://schemas.microsoft.com/office/drawing/2014/main" id="{9849499A-E5DA-4DB7-A7B8-194E87075D0C}"/>
-              </a:ext>
-            </a:extLst>
-          </p:cNvPr>
-          <p:cNvSpPr>
-            <a:spLocks noGrp="1"/>
-          </p:cNvSpPr>
-          <p:nvPr/>
-        </p:nvSpPr>
-        <p:spPr>
-          <a:xfrm>
-            <a:off x="952500" y="5095875"/>
-            <a:ext cx="10287000" cy="304800"/>
-          </a:xfrm>
-          <a:prstGeom prst="rect">
-            <a:avLst/>
-          </a:prstGeom>
-          <a:noFill/>
-          <a:ln w="0">
-            <a:noFill/>
-            <a:prstDash val="solid"/>
-          </a:ln>
-        </p:spPr>
-        <p:txBody>
-          <a:bodyPr anchor="t"/>
-          <a:lstStyle/>
-          <a:p>
-            <a:pPr algn="ctr">
-              <a:defRPr sz="1725" b="1">
-                <a:solidFill>
-                  <a:srgbClr val="167C80"/>
-                </a:solidFill>
-                <a:latin typeface="Aptos"/>
-                <a:ea typeface="Aptos"/>
-                <a:cs typeface="Aptos"/>
-              </a:defRPr>
-            </a:pPr>
-            <a:r>
-              <a:rPr sz="1725" b="1">
-                <a:solidFill>
-                  <a:srgbClr val="167C80"/>
-                </a:solidFill>
-                <a:latin typeface="Aptos"/>
-                <a:ea typeface="Aptos"/>
-                <a:cs typeface="Aptos"/>
-              </a:rPr>
-              <a:t>Cada decisão preserva: classe, evidência lexical, versão da memória e origem da decisão.</a:t>
-            </a:r>
-          </a:p>
-        </p:txBody>
-      </p:sp>
-    </p:spTree>
-    <p:extLst>
-      <p:ext uri="{BB962C8B-B14F-4D97-AF65-F5344CB8AC3E}">
-        <p14:creationId xmlns:p14="http://schemas.microsoft.com/office/powerpoint/2010/main" val="1782707264"/>
-      </p:ext>
-    </p:extLst>
-  </p:cSld>
-  <p:clrMapOvr>
-    <a:masterClrMapping/>
-  </p:clrMapOvr>
-</p:sld>
-</file>
-
-<file path=ppt/slides/slide12.xml><?xml version="1.0" encoding="utf-8"?>
-<p:sld xmlns:a="http://schemas.openxmlformats.org/drawingml/2006/main" xmlns:r="http://schemas.openxmlformats.org/officeDocument/2006/relationships" xmlns:p="http://schemas.openxmlformats.org/presentationml/2006/main">
-  <p:cSld>
-    <p:bg>
-      <p:bgPr>
-        <a:solidFill>
-          <a:srgbClr val="F7F8FA"/>
-        </a:solidFill>
-        <a:effectLst/>
-      </p:bgPr>
-    </p:bg>
-    <p:spTree>
-      <p:nvGrpSpPr>
-        <p:cNvPr id="1" name=""/>
-        <p:cNvGrpSpPr/>
-        <p:nvPr/>
-      </p:nvGrpSpPr>
-      <p:grpSpPr>
-        <a:xfrm>
-          <a:off x="0" y="0"/>
-          <a:ext cx="0" cy="0"/>
-          <a:chOff x="0" y="0"/>
-          <a:chExt cx="0" cy="0"/>
-        </a:xfrm>
-      </p:grpSpPr>
-      <p:sp>
-        <p:nvSpPr>
-          <p:cNvPr id="18" name="Retângulo 17">
-            <a:extLst>
-              <a:ext uri="{FF2B5EF4-FFF2-40B4-BE49-F238E27FC236}">
-                <a16:creationId xmlns:a16="http://schemas.microsoft.com/office/drawing/2014/main" id="{D8D04F84-3E3B-4A19-B8A8-794EBC723408}"/>
-              </a:ext>
-            </a:extLst>
-          </p:cNvPr>
-          <p:cNvSpPr>
-            <a:spLocks noGrp="1"/>
-          </p:cNvSpPr>
-          <p:nvPr/>
-        </p:nvSpPr>
-        <p:spPr>
-          <a:xfrm>
-            <a:off x="685800" y="514350"/>
-            <a:ext cx="609600" cy="57150"/>
-          </a:xfrm>
-          <a:prstGeom prst="rect">
-            <a:avLst/>
-          </a:prstGeom>
-          <a:solidFill>
-            <a:srgbClr val="F4B942"/>
-          </a:solidFill>
-          <a:ln w="0">
-            <a:solidFill>
-              <a:srgbClr val="F4B942"/>
-            </a:solidFill>
-            <a:prstDash val="solid"/>
-          </a:ln>
-        </p:spPr>
-        <p:txBody>
-          <a:bodyPr/>
-          <a:lstStyle/>
-          <a:p>
-            <a:endParaRPr lang="pt-PT"/>
-          </a:p>
-        </p:txBody>
-      </p:sp>
-      <p:sp>
-        <p:nvSpPr>
-          <p:cNvPr id="2" name="Retângulo 1">
-            <a:extLst>
-              <a:ext uri="{FF2B5EF4-FFF2-40B4-BE49-F238E27FC236}">
-                <a16:creationId xmlns:a16="http://schemas.microsoft.com/office/drawing/2014/main" id="{906D603B-C289-48FC-A6C5-C6BFFE4D1D61}"/>
-              </a:ext>
-            </a:extLst>
-          </p:cNvPr>
-          <p:cNvSpPr>
-            <a:spLocks noGrp="1"/>
-          </p:cNvSpPr>
-          <p:nvPr/>
-        </p:nvSpPr>
-        <p:spPr>
-          <a:xfrm>
-            <a:off x="685800" y="685800"/>
-            <a:ext cx="2857500" cy="228600"/>
-          </a:xfrm>
-          <a:prstGeom prst="rect">
-            <a:avLst/>
-          </a:prstGeom>
-          <a:noFill/>
-          <a:ln w="0">
-            <a:noFill/>
-            <a:prstDash val="solid"/>
-          </a:ln>
-        </p:spPr>
-        <p:txBody>
-          <a:bodyPr anchor="t"/>
-          <a:lstStyle/>
-          <a:p>
-            <a:pPr algn="l">
-              <a:defRPr sz="1125" b="1">
-                <a:solidFill>
-                  <a:srgbClr val="2F5D8C"/>
-                </a:solidFill>
-                <a:latin typeface="Aptos"/>
-                <a:ea typeface="Aptos"/>
-                <a:cs typeface="Aptos"/>
-              </a:defRPr>
-            </a:pPr>
-            <a:r>
-              <a:rPr sz="1125" b="1">
-                <a:solidFill>
-                  <a:srgbClr val="2F5D8C"/>
-                </a:solidFill>
-                <a:latin typeface="Aptos"/>
-                <a:ea typeface="Aptos"/>
-                <a:cs typeface="Aptos"/>
-              </a:rPr>
-              <a:t>AT | DIAGNÓSTICO DA RODADA</a:t>
-            </a:r>
-          </a:p>
-        </p:txBody>
-      </p:sp>
-      <p:sp>
-        <p:nvSpPr>
-          <p:cNvPr id="3" name="Retângulo 2">
-            <a:extLst>
-              <a:ext uri="{FF2B5EF4-FFF2-40B4-BE49-F238E27FC236}">
-                <a16:creationId xmlns:a16="http://schemas.microsoft.com/office/drawing/2014/main" id="{85419313-EBF6-492D-B6A8-A5A058891134}"/>
-              </a:ext>
-            </a:extLst>
-          </p:cNvPr>
-          <p:cNvSpPr>
-            <a:spLocks noGrp="1"/>
-          </p:cNvSpPr>
-          <p:nvPr/>
-        </p:nvSpPr>
-        <p:spPr>
-          <a:xfrm>
-            <a:off x="685800" y="1009650"/>
-            <a:ext cx="10287000" cy="533400"/>
-          </a:xfrm>
-          <a:prstGeom prst="rect">
-            <a:avLst/>
-          </a:prstGeom>
-          <a:noFill/>
-          <a:ln w="0">
-            <a:noFill/>
-            <a:prstDash val="solid"/>
-          </a:ln>
-        </p:spPr>
-        <p:txBody>
-          <a:bodyPr anchor="t"/>
-          <a:lstStyle/>
-          <a:p>
-            <a:pPr algn="l">
-              <a:defRPr sz="2625" b="1">
-                <a:solidFill>
-                  <a:srgbClr val="14213D"/>
-                </a:solidFill>
-                <a:latin typeface="Aptos"/>
-                <a:ea typeface="Aptos"/>
-                <a:cs typeface="Aptos"/>
-              </a:defRPr>
-            </a:pPr>
-            <a:r>
-              <a:rPr sz="2625" b="1">
-                <a:solidFill>
-                  <a:srgbClr val="14213D"/>
-                </a:solidFill>
-                <a:latin typeface="Aptos"/>
-                <a:ea typeface="Aptos"/>
-                <a:cs typeface="Aptos"/>
-              </a:rPr>
-              <a:t>A memória WNN absorveu 83,33% da reserva antes de qualquer revisão por LLM</a:t>
-            </a:r>
-          </a:p>
-        </p:txBody>
-      </p:sp>
-      <p:sp>
-        <p:nvSpPr>
-          <p:cNvPr id="4" name="Retângulo 3">
-            <a:extLst>
-              <a:ext uri="{FF2B5EF4-FFF2-40B4-BE49-F238E27FC236}">
-                <a16:creationId xmlns:a16="http://schemas.microsoft.com/office/drawing/2014/main" id="{3DD0C617-01BD-4138-B5F3-8840A9AAEE8C}"/>
-              </a:ext>
-            </a:extLst>
-          </p:cNvPr>
-          <p:cNvSpPr>
-            <a:spLocks noGrp="1"/>
-          </p:cNvSpPr>
-          <p:nvPr/>
-        </p:nvSpPr>
-        <p:spPr>
-          <a:xfrm>
-            <a:off x="10953750" y="685800"/>
-            <a:ext cx="533400" cy="266700"/>
-          </a:xfrm>
-          <a:prstGeom prst="rect">
-            <a:avLst/>
-          </a:prstGeom>
-          <a:noFill/>
-          <a:ln w="0">
-            <a:noFill/>
-            <a:prstDash val="solid"/>
-          </a:ln>
-        </p:spPr>
-        <p:txBody>
-          <a:bodyPr anchor="t"/>
-          <a:lstStyle/>
-          <a:p>
-            <a:pPr algn="r">
-              <a:defRPr sz="1200" b="1">
-                <a:solidFill>
-                  <a:srgbClr val="5E6B7A"/>
-                </a:solidFill>
-                <a:latin typeface="Aptos"/>
-                <a:ea typeface="Aptos"/>
-                <a:cs typeface="Aptos"/>
-              </a:defRPr>
-            </a:pPr>
-            <a:r>
-              <a:rPr sz="1200" b="1">
-                <a:solidFill>
-                  <a:srgbClr val="5E6B7A"/>
-                </a:solidFill>
-                <a:latin typeface="Aptos"/>
-                <a:ea typeface="Aptos"/>
-                <a:cs typeface="Aptos"/>
-              </a:rPr>
-              <a:t>11</a:t>
-            </a:r>
-          </a:p>
-        </p:txBody>
-      </p:sp>
-      <p:sp>
-        <p:nvSpPr>
-          <p:cNvPr id="5" name="Retângulo 4">
-            <a:extLst>
-              <a:ext uri="{FF2B5EF4-FFF2-40B4-BE49-F238E27FC236}">
-                <a16:creationId xmlns:a16="http://schemas.microsoft.com/office/drawing/2014/main" id="{38868E87-64D3-42EC-9602-61EF7515712D}"/>
-              </a:ext>
-            </a:extLst>
-          </p:cNvPr>
-          <p:cNvSpPr>
-            <a:spLocks noGrp="1"/>
-          </p:cNvSpPr>
-          <p:nvPr/>
-        </p:nvSpPr>
-        <p:spPr>
-          <a:xfrm>
-            <a:off x="857250" y="2047875"/>
-            <a:ext cx="4286250" cy="266700"/>
-          </a:xfrm>
-          <a:prstGeom prst="rect">
-            <a:avLst/>
-          </a:prstGeom>
-          <a:noFill/>
-          <a:ln w="0">
-            <a:noFill/>
-            <a:prstDash val="solid"/>
-          </a:ln>
-        </p:spPr>
-        <p:txBody>
-          <a:bodyPr anchor="t"/>
-          <a:lstStyle/>
-          <a:p>
-            <a:pPr algn="l">
-              <a:defRPr sz="1725" b="1">
-                <a:solidFill>
-                  <a:srgbClr val="2F5D8C"/>
-                </a:solidFill>
-                <a:latin typeface="Aptos"/>
-                <a:ea typeface="Aptos"/>
-                <a:cs typeface="Aptos"/>
-              </a:defRPr>
-            </a:pPr>
-            <a:r>
-              <a:rPr sz="1725" b="1">
-                <a:solidFill>
-                  <a:srgbClr val="2F5D8C"/>
-                </a:solidFill>
-                <a:latin typeface="Aptos"/>
-                <a:ea typeface="Aptos"/>
-                <a:cs typeface="Aptos"/>
-              </a:rPr>
-              <a:t>Base total: 8.310 notícias</a:t>
-            </a:r>
-          </a:p>
-        </p:txBody>
-      </p:sp>
-      <p:sp>
-        <p:nvSpPr>
-          <p:cNvPr id="6" name="Retângulo 5">
-            <a:extLst>
-              <a:ext uri="{FF2B5EF4-FFF2-40B4-BE49-F238E27FC236}">
-                <a16:creationId xmlns:a16="http://schemas.microsoft.com/office/drawing/2014/main" id="{07982D1D-124B-44CE-AFB1-E55282E1484F}"/>
-              </a:ext>
-            </a:extLst>
-          </p:cNvPr>
-          <p:cNvSpPr>
-            <a:spLocks noGrp="1"/>
-          </p:cNvSpPr>
-          <p:nvPr/>
-        </p:nvSpPr>
-        <p:spPr>
-          <a:xfrm>
-            <a:off x="857250" y="2714625"/>
-            <a:ext cx="2619375" cy="228600"/>
-          </a:xfrm>
-          <a:prstGeom prst="rect">
-            <a:avLst/>
-          </a:prstGeom>
-          <a:noFill/>
-          <a:ln w="0">
-            <a:noFill/>
-            <a:prstDash val="solid"/>
-          </a:ln>
-        </p:spPr>
-        <p:txBody>
-          <a:bodyPr anchor="t"/>
-          <a:lstStyle/>
-          <a:p>
-            <a:pPr algn="l">
-              <a:defRPr sz="1425" b="1">
-                <a:solidFill>
-                  <a:srgbClr val="14213D"/>
-                </a:solidFill>
-                <a:latin typeface="Aptos"/>
-                <a:ea typeface="Aptos"/>
-                <a:cs typeface="Aptos"/>
-              </a:defRPr>
-            </a:pPr>
-            <a:r>
-              <a:rPr sz="1425" b="1">
-                <a:solidFill>
-                  <a:srgbClr val="14213D"/>
-                </a:solidFill>
-                <a:latin typeface="Aptos"/>
-                <a:ea typeface="Aptos"/>
-                <a:cs typeface="Aptos"/>
-              </a:rPr>
-              <a:t>Fundação temática</a:t>
-            </a:r>
-          </a:p>
-        </p:txBody>
-      </p:sp>
-      <p:sp>
-        <p:nvSpPr>
-          <p:cNvPr id="7" name="Retângulo 6">
-            <a:extLst>
-              <a:ext uri="{FF2B5EF4-FFF2-40B4-BE49-F238E27FC236}">
-                <a16:creationId xmlns:a16="http://schemas.microsoft.com/office/drawing/2014/main" id="{452693D8-955C-4528-8FA1-7BACE511D8B9}"/>
-              </a:ext>
-            </a:extLst>
-          </p:cNvPr>
-          <p:cNvSpPr>
-            <a:spLocks noGrp="1"/>
-          </p:cNvSpPr>
-          <p:nvPr/>
-        </p:nvSpPr>
-        <p:spPr>
-          <a:xfrm>
-            <a:off x="3619500" y="2743200"/>
-            <a:ext cx="753836" cy="228600"/>
-          </a:xfrm>
-          <a:prstGeom prst="rect">
-            <a:avLst/>
-          </a:prstGeom>
-          <a:solidFill>
-            <a:srgbClr val="F4B942"/>
-          </a:solidFill>
-          <a:ln w="0">
-            <a:solidFill>
-              <a:srgbClr val="F4B942"/>
-            </a:solidFill>
-            <a:prstDash val="solid"/>
-          </a:ln>
-        </p:spPr>
-        <p:txBody>
-          <a:bodyPr/>
-          <a:lstStyle/>
-          <a:p>
-            <a:endParaRPr lang="pt-PT"/>
-          </a:p>
-        </p:txBody>
-      </p:sp>
-      <p:sp>
-        <p:nvSpPr>
-          <p:cNvPr id="8" name="Retângulo 7">
-            <a:extLst>
-              <a:ext uri="{FF2B5EF4-FFF2-40B4-BE49-F238E27FC236}">
-                <a16:creationId xmlns:a16="http://schemas.microsoft.com/office/drawing/2014/main" id="{D861EF2D-ED3C-40C9-8484-4025BBC5445F}"/>
-              </a:ext>
-            </a:extLst>
-          </p:cNvPr>
-          <p:cNvSpPr>
-            <a:spLocks noGrp="1"/>
-          </p:cNvSpPr>
-          <p:nvPr/>
-        </p:nvSpPr>
-        <p:spPr>
-          <a:xfrm>
-            <a:off x="8572500" y="2714625"/>
-            <a:ext cx="1809750" cy="228600"/>
-          </a:xfrm>
-          <a:prstGeom prst="rect">
-            <a:avLst/>
-          </a:prstGeom>
-          <a:noFill/>
-          <a:ln w="0">
-            <a:noFill/>
-            <a:prstDash val="solid"/>
-          </a:ln>
-        </p:spPr>
-        <p:txBody>
-          <a:bodyPr anchor="t"/>
-          <a:lstStyle/>
-          <a:p>
-            <a:pPr algn="l">
-              <a:defRPr sz="1425" b="1">
-                <a:solidFill>
-                  <a:srgbClr val="F4B942"/>
-                </a:solidFill>
-                <a:latin typeface="Aptos"/>
-                <a:ea typeface="Aptos"/>
-                <a:cs typeface="Aptos"/>
-              </a:defRPr>
-            </a:pPr>
-            <a:r>
-              <a:rPr sz="1425" b="1">
-                <a:solidFill>
-                  <a:srgbClr val="F4B942"/>
-                </a:solidFill>
-                <a:latin typeface="Aptos"/>
-                <a:ea typeface="Aptos"/>
-                <a:cs typeface="Aptos"/>
-              </a:rPr>
-              <a:t>831  |  10%</a:t>
-            </a:r>
-          </a:p>
-        </p:txBody>
-      </p:sp>
-      <p:sp>
-        <p:nvSpPr>
-          <p:cNvPr id="9" name="Retângulo 8">
-            <a:extLst>
-              <a:ext uri="{FF2B5EF4-FFF2-40B4-BE49-F238E27FC236}">
-                <a16:creationId xmlns:a16="http://schemas.microsoft.com/office/drawing/2014/main" id="{DE9FBF2E-C2B0-4E28-AB4D-E6540A8728A0}"/>
-              </a:ext>
-            </a:extLst>
-          </p:cNvPr>
-          <p:cNvSpPr>
-            <a:spLocks noGrp="1"/>
-          </p:cNvSpPr>
-          <p:nvPr/>
-        </p:nvSpPr>
-        <p:spPr>
-          <a:xfrm>
-            <a:off x="857250" y="3514725"/>
-            <a:ext cx="2619375" cy="228600"/>
-          </a:xfrm>
-          <a:prstGeom prst="rect">
-            <a:avLst/>
-          </a:prstGeom>
-          <a:noFill/>
-          <a:ln w="0">
-            <a:noFill/>
-            <a:prstDash val="solid"/>
-          </a:ln>
-        </p:spPr>
-        <p:txBody>
-          <a:bodyPr anchor="t"/>
-          <a:lstStyle/>
-          <a:p>
-            <a:pPr algn="l">
-              <a:defRPr sz="1425" b="1">
-                <a:solidFill>
-                  <a:srgbClr val="14213D"/>
-                </a:solidFill>
-                <a:latin typeface="Aptos"/>
-                <a:ea typeface="Aptos"/>
-                <a:cs typeface="Aptos"/>
-              </a:defRPr>
-            </a:pPr>
-            <a:r>
-              <a:rPr sz="1425" b="1">
-                <a:solidFill>
-                  <a:srgbClr val="14213D"/>
-                </a:solidFill>
-                <a:latin typeface="Aptos"/>
-                <a:ea typeface="Aptos"/>
-                <a:cs typeface="Aptos"/>
-              </a:rPr>
-              <a:t>WNN direta na reserva</a:t>
-            </a:r>
-          </a:p>
-        </p:txBody>
-      </p:sp>
-      <p:sp>
-        <p:nvSpPr>
-          <p:cNvPr id="10" name="Retângulo 9">
-            <a:extLst>
-              <a:ext uri="{FF2B5EF4-FFF2-40B4-BE49-F238E27FC236}">
-                <a16:creationId xmlns:a16="http://schemas.microsoft.com/office/drawing/2014/main" id="{9ACB102D-88D0-4D88-9E94-6E7C80E497DF}"/>
-              </a:ext>
-            </a:extLst>
-          </p:cNvPr>
-          <p:cNvSpPr>
-            <a:spLocks noGrp="1"/>
-          </p:cNvSpPr>
-          <p:nvPr/>
-        </p:nvSpPr>
-        <p:spPr>
-          <a:xfrm>
-            <a:off x="3619500" y="3543300"/>
-            <a:ext cx="5653314" cy="228600"/>
-          </a:xfrm>
-          <a:prstGeom prst="rect">
-            <a:avLst/>
-          </a:prstGeom>
-          <a:solidFill>
-            <a:srgbClr val="167C80"/>
-          </a:solidFill>
-          <a:ln w="0">
-            <a:solidFill>
-              <a:srgbClr val="167C80"/>
-            </a:solidFill>
-            <a:prstDash val="solid"/>
-          </a:ln>
-        </p:spPr>
-        <p:txBody>
-          <a:bodyPr/>
-          <a:lstStyle/>
-          <a:p>
-            <a:endParaRPr lang="pt-PT"/>
-          </a:p>
-        </p:txBody>
-      </p:sp>
-      <p:sp>
-        <p:nvSpPr>
-          <p:cNvPr id="11" name="Retângulo 10">
-            <a:extLst>
-              <a:ext uri="{FF2B5EF4-FFF2-40B4-BE49-F238E27FC236}">
-                <a16:creationId xmlns:a16="http://schemas.microsoft.com/office/drawing/2014/main" id="{685B45A1-02FE-478B-8EC0-4C54737823F5}"/>
-              </a:ext>
-            </a:extLst>
-          </p:cNvPr>
-          <p:cNvSpPr>
-            <a:spLocks noGrp="1"/>
-          </p:cNvSpPr>
-          <p:nvPr/>
-        </p:nvSpPr>
-        <p:spPr>
-          <a:xfrm>
-            <a:off x="8572500" y="3514725"/>
-            <a:ext cx="1809750" cy="228600"/>
-          </a:xfrm>
-          <a:prstGeom prst="rect">
-            <a:avLst/>
-          </a:prstGeom>
-          <a:noFill/>
-          <a:ln w="0">
-            <a:noFill/>
-            <a:prstDash val="solid"/>
-          </a:ln>
-        </p:spPr>
-        <p:txBody>
-          <a:bodyPr anchor="t"/>
-          <a:lstStyle/>
-          <a:p>
-            <a:pPr algn="l">
-              <a:defRPr sz="1425" b="1">
-                <a:solidFill>
-                  <a:srgbClr val="167C80"/>
-                </a:solidFill>
-                <a:latin typeface="Aptos"/>
-                <a:ea typeface="Aptos"/>
-                <a:cs typeface="Aptos"/>
-              </a:defRPr>
-            </a:pPr>
-            <a:r>
-              <a:rPr sz="1425" b="1">
-                <a:solidFill>
-                  <a:srgbClr val="167C80"/>
-                </a:solidFill>
-                <a:latin typeface="Aptos"/>
-                <a:ea typeface="Aptos"/>
-                <a:cs typeface="Aptos"/>
-              </a:rPr>
-              <a:t>6.232  |  83,33%</a:t>
-            </a:r>
-          </a:p>
-        </p:txBody>
-      </p:sp>
-      <p:sp>
-        <p:nvSpPr>
-          <p:cNvPr id="12" name="Retângulo 11">
-            <a:extLst>
-              <a:ext uri="{FF2B5EF4-FFF2-40B4-BE49-F238E27FC236}">
-                <a16:creationId xmlns:a16="http://schemas.microsoft.com/office/drawing/2014/main" id="{FC7CDEC2-A0F3-40F6-BB42-5821DF596835}"/>
-              </a:ext>
-            </a:extLst>
-          </p:cNvPr>
-          <p:cNvSpPr>
-            <a:spLocks noGrp="1"/>
-          </p:cNvSpPr>
-          <p:nvPr/>
-        </p:nvSpPr>
-        <p:spPr>
-          <a:xfrm>
-            <a:off x="857250" y="4314825"/>
-            <a:ext cx="2619375" cy="228600"/>
-          </a:xfrm>
-          <a:prstGeom prst="rect">
-            <a:avLst/>
-          </a:prstGeom>
-          <a:noFill/>
-          <a:ln w="0">
-            <a:noFill/>
-            <a:prstDash val="solid"/>
-          </a:ln>
-        </p:spPr>
-        <p:txBody>
-          <a:bodyPr anchor="t"/>
-          <a:lstStyle/>
-          <a:p>
-            <a:pPr algn="l">
-              <a:defRPr sz="1425" b="1">
-                <a:solidFill>
-                  <a:srgbClr val="14213D"/>
-                </a:solidFill>
-                <a:latin typeface="Aptos"/>
-                <a:ea typeface="Aptos"/>
-                <a:cs typeface="Aptos"/>
-              </a:defRPr>
-            </a:pPr>
-            <a:r>
-              <a:rPr sz="1425" b="1">
-                <a:solidFill>
-                  <a:srgbClr val="14213D"/>
-                </a:solidFill>
-                <a:latin typeface="Aptos"/>
-                <a:ea typeface="Aptos"/>
-                <a:cs typeface="Aptos"/>
-              </a:rPr>
-              <a:t>Residual pós-WNN</a:t>
-            </a:r>
-          </a:p>
-        </p:txBody>
-      </p:sp>
-      <p:sp>
-        <p:nvSpPr>
-          <p:cNvPr id="13" name="Retângulo 12">
-            <a:extLst>
-              <a:ext uri="{FF2B5EF4-FFF2-40B4-BE49-F238E27FC236}">
-                <a16:creationId xmlns:a16="http://schemas.microsoft.com/office/drawing/2014/main" id="{0DE16BC1-C331-40CE-83AA-F37FB193964D}"/>
-              </a:ext>
-            </a:extLst>
-          </p:cNvPr>
-          <p:cNvSpPr>
-            <a:spLocks noGrp="1"/>
-          </p:cNvSpPr>
-          <p:nvPr/>
-        </p:nvSpPr>
-        <p:spPr>
-          <a:xfrm>
-            <a:off x="3619500" y="4343400"/>
-            <a:ext cx="1131207" cy="228600"/>
-          </a:xfrm>
-          <a:prstGeom prst="rect">
-            <a:avLst/>
-          </a:prstGeom>
-          <a:solidFill>
-            <a:srgbClr val="D96C4B"/>
-          </a:solidFill>
-          <a:ln w="0">
-            <a:solidFill>
-              <a:srgbClr val="D96C4B"/>
-            </a:solidFill>
-            <a:prstDash val="solid"/>
-          </a:ln>
-        </p:spPr>
-        <p:txBody>
-          <a:bodyPr/>
-          <a:lstStyle/>
-          <a:p>
-            <a:endParaRPr lang="pt-PT"/>
-          </a:p>
-        </p:txBody>
-      </p:sp>
-      <p:sp>
-        <p:nvSpPr>
-          <p:cNvPr id="14" name="Retângulo 13">
-            <a:extLst>
-              <a:ext uri="{FF2B5EF4-FFF2-40B4-BE49-F238E27FC236}">
-                <a16:creationId xmlns:a16="http://schemas.microsoft.com/office/drawing/2014/main" id="{21FC0E40-658C-44AC-A1C1-2E68AF8E610F}"/>
-              </a:ext>
-            </a:extLst>
-          </p:cNvPr>
-          <p:cNvSpPr>
-            <a:spLocks noGrp="1"/>
-          </p:cNvSpPr>
-          <p:nvPr/>
-        </p:nvSpPr>
-        <p:spPr>
-          <a:xfrm>
-            <a:off x="8572500" y="4314825"/>
-            <a:ext cx="1809750" cy="228600"/>
-          </a:xfrm>
-          <a:prstGeom prst="rect">
-            <a:avLst/>
-          </a:prstGeom>
-          <a:noFill/>
-          <a:ln w="0">
-            <a:noFill/>
-            <a:prstDash val="solid"/>
-          </a:ln>
-        </p:spPr>
-        <p:txBody>
-          <a:bodyPr anchor="t"/>
-          <a:lstStyle/>
-          <a:p>
-            <a:pPr algn="l">
-              <a:defRPr sz="1425" b="1">
-                <a:solidFill>
-                  <a:srgbClr val="D96C4B"/>
-                </a:solidFill>
-                <a:latin typeface="Aptos"/>
-                <a:ea typeface="Aptos"/>
-                <a:cs typeface="Aptos"/>
-              </a:defRPr>
-            </a:pPr>
-            <a:r>
-              <a:rPr sz="1425" b="1">
-                <a:solidFill>
-                  <a:srgbClr val="D96C4B"/>
-                </a:solidFill>
-                <a:latin typeface="Aptos"/>
-                <a:ea typeface="Aptos"/>
-                <a:cs typeface="Aptos"/>
-              </a:rPr>
-              <a:t>1.247  |  16,66%</a:t>
-            </a:r>
-          </a:p>
-        </p:txBody>
-      </p:sp>
-      <p:sp>
-        <p:nvSpPr>
-          <p:cNvPr id="15" name="Retângulo: Cantos Arredondados 14">
-            <a:extLst>
-              <a:ext uri="{FF2B5EF4-FFF2-40B4-BE49-F238E27FC236}">
-                <a16:creationId xmlns:a16="http://schemas.microsoft.com/office/drawing/2014/main" id="{2B28E106-2C8D-494A-8BC7-0A32ECFA1917}"/>
-              </a:ext>
-            </a:extLst>
-          </p:cNvPr>
-          <p:cNvSpPr>
-            <a:spLocks noGrp="1"/>
-          </p:cNvSpPr>
-          <p:nvPr/>
-        </p:nvSpPr>
-        <p:spPr>
-          <a:xfrm>
-            <a:off x="7000875" y="4972050"/>
-            <a:ext cx="3524250" cy="762000"/>
-          </a:xfrm>
-          <a:prstGeom prst="roundRect">
-            <a:avLst>
-              <a:gd name="adj" fmla="val 15000"/>
-            </a:avLst>
-          </a:prstGeom>
-          <a:solidFill>
-            <a:srgbClr val="FFF8E6"/>
-          </a:solidFill>
-          <a:ln w="9525">
-            <a:solidFill>
-              <a:srgbClr val="F0D18A"/>
-            </a:solidFill>
-            <a:prstDash val="solid"/>
-          </a:ln>
-        </p:spPr>
-        <p:txBody>
-          <a:bodyPr/>
-          <a:lstStyle/>
-          <a:p>
-            <a:endParaRPr lang="pt-PT"/>
-          </a:p>
-        </p:txBody>
-      </p:sp>
-      <p:sp>
-        <p:nvSpPr>
-          <p:cNvPr id="16" name="Retângulo 15">
-            <a:extLst>
-              <a:ext uri="{FF2B5EF4-FFF2-40B4-BE49-F238E27FC236}">
-                <a16:creationId xmlns:a16="http://schemas.microsoft.com/office/drawing/2014/main" id="{1DEE18B3-070F-4902-A049-5A159DAE0873}"/>
-              </a:ext>
-            </a:extLst>
-          </p:cNvPr>
-          <p:cNvSpPr>
-            <a:spLocks noGrp="1"/>
-          </p:cNvSpPr>
-          <p:nvPr/>
-        </p:nvSpPr>
-        <p:spPr>
-          <a:xfrm>
-            <a:off x="7258050" y="5219700"/>
-            <a:ext cx="3095625" cy="228600"/>
-          </a:xfrm>
-          <a:prstGeom prst="rect">
-            <a:avLst/>
-          </a:prstGeom>
-          <a:noFill/>
-          <a:ln w="0">
-            <a:noFill/>
-            <a:prstDash val="solid"/>
-          </a:ln>
-        </p:spPr>
-        <p:txBody>
-          <a:bodyPr anchor="t"/>
-          <a:lstStyle/>
-          <a:p>
-            <a:pPr algn="ctr">
-              <a:defRPr sz="1500" b="1">
-                <a:solidFill>
-                  <a:srgbClr val="D96C4B"/>
-                </a:solidFill>
-                <a:latin typeface="Aptos"/>
-                <a:ea typeface="Aptos"/>
-                <a:cs typeface="Aptos"/>
-              </a:defRPr>
-            </a:pPr>
-            <a:r>
-              <a:rPr sz="1500" b="1">
-                <a:solidFill>
-                  <a:srgbClr val="D96C4B"/>
-                </a:solidFill>
-                <a:latin typeface="Aptos"/>
-                <a:ea typeface="Aptos"/>
-                <a:cs typeface="Aptos"/>
-              </a:rPr>
-              <a:t>Cuidado: cobertura não é acurácia.</a:t>
-            </a:r>
-          </a:p>
-        </p:txBody>
-      </p:sp>
-      <p:sp>
-        <p:nvSpPr>
-          <p:cNvPr id="17" name="Retângulo 16">
-            <a:extLst>
-              <a:ext uri="{FF2B5EF4-FFF2-40B4-BE49-F238E27FC236}">
-                <a16:creationId xmlns:a16="http://schemas.microsoft.com/office/drawing/2014/main" id="{6DA864C7-477C-4B27-894A-B43F566E16FB}"/>
-              </a:ext>
-            </a:extLst>
-          </p:cNvPr>
-          <p:cNvSpPr>
-            <a:spLocks noGrp="1"/>
-          </p:cNvSpPr>
-          <p:nvPr/>
-        </p:nvSpPr>
-        <p:spPr>
-          <a:xfrm>
-            <a:off x="857250" y="6048375"/>
-            <a:ext cx="9906000" cy="247650"/>
-          </a:xfrm>
-          <a:prstGeom prst="rect">
-            <a:avLst/>
-          </a:prstGeom>
-          <a:noFill/>
-          <a:ln w="0">
-            <a:noFill/>
-            <a:prstDash val="solid"/>
-          </a:ln>
-        </p:spPr>
-        <p:txBody>
-          <a:bodyPr anchor="t"/>
-          <a:lstStyle/>
-          <a:p>
-            <a:pPr algn="l">
-              <a:defRPr sz="1275" b="0">
-                <a:solidFill>
-                  <a:srgbClr val="5E6B7A"/>
-                </a:solidFill>
-                <a:latin typeface="Aptos"/>
-                <a:ea typeface="Aptos"/>
-                <a:cs typeface="Aptos"/>
-              </a:defRPr>
-            </a:pPr>
-            <a:r>
-              <a:rPr sz="1275" b="0">
-                <a:solidFill>
-                  <a:srgbClr val="5E6B7A"/>
-                </a:solidFill>
-                <a:latin typeface="Aptos"/>
-                <a:ea typeface="Aptos"/>
-                <a:cs typeface="Aptos"/>
-              </a:rPr>
-              <a:t>A redução de chamadas à LLM é operacional; qualidade exige validação humana e métricas de precisão, revocação e F1.</a:t>
-            </a:r>
-          </a:p>
-        </p:txBody>
-      </p:sp>
-    </p:spTree>
-    <p:extLst>
-      <p:ext uri="{BB962C8B-B14F-4D97-AF65-F5344CB8AC3E}">
-        <p14:creationId xmlns:p14="http://schemas.microsoft.com/office/powerpoint/2010/main" val="296033023"/>
-      </p:ext>
-    </p:extLst>
-  </p:cSld>
-  <p:clrMapOvr>
-    <a:masterClrMapping/>
-  </p:clrMapOvr>
-</p:sld>
-</file>
-
-<file path=ppt/slides/slide13.xml><?xml version="1.0" encoding="utf-8"?>
-<p:sld xmlns:a="http://schemas.openxmlformats.org/drawingml/2006/main" xmlns:r="http://schemas.openxmlformats.org/officeDocument/2006/relationships" xmlns:p="http://schemas.openxmlformats.org/presentationml/2006/main">
-  <p:cSld>
-    <p:bg>
-      <p:bgPr>
-        <a:solidFill>
-          <a:srgbClr val="F7F8FA"/>
-        </a:solidFill>
-        <a:effectLst/>
-      </p:bgPr>
-    </p:bg>
-    <p:spTree>
-      <p:nvGrpSpPr>
-        <p:cNvPr id="1" name=""/>
-        <p:cNvGrpSpPr/>
-        <p:nvPr/>
-      </p:nvGrpSpPr>
-      <p:grpSpPr>
-        <a:xfrm>
-          <a:off x="0" y="0"/>
-          <a:ext cx="0" cy="0"/>
-          <a:chOff x="0" y="0"/>
-          <a:chExt cx="0" cy="0"/>
-        </a:xfrm>
-      </p:grpSpPr>
-      <p:sp>
-        <p:nvSpPr>
-          <p:cNvPr id="13" name="Retângulo 12">
-            <a:extLst>
-              <a:ext uri="{FF2B5EF4-FFF2-40B4-BE49-F238E27FC236}">
-                <a16:creationId xmlns:a16="http://schemas.microsoft.com/office/drawing/2014/main" id="{46C21316-E056-48D1-9FDE-9A5F3984F9A1}"/>
-              </a:ext>
-            </a:extLst>
-          </p:cNvPr>
-          <p:cNvSpPr>
-            <a:spLocks noGrp="1"/>
-          </p:cNvSpPr>
-          <p:nvPr/>
-        </p:nvSpPr>
-        <p:spPr>
-          <a:xfrm>
-            <a:off x="685800" y="514350"/>
-            <a:ext cx="609600" cy="57150"/>
-          </a:xfrm>
-          <a:prstGeom prst="rect">
-            <a:avLst/>
-          </a:prstGeom>
-          <a:solidFill>
-            <a:srgbClr val="F4B942"/>
-          </a:solidFill>
-          <a:ln w="0">
-            <a:solidFill>
-              <a:srgbClr val="F4B942"/>
-            </a:solidFill>
-            <a:prstDash val="solid"/>
-          </a:ln>
-        </p:spPr>
-        <p:txBody>
-          <a:bodyPr/>
-          <a:lstStyle/>
-          <a:p>
-            <a:endParaRPr lang="pt-PT"/>
-          </a:p>
-        </p:txBody>
-      </p:sp>
-      <p:sp>
-        <p:nvSpPr>
-          <p:cNvPr id="2" name="Retângulo 1">
-            <a:extLst>
-              <a:ext uri="{FF2B5EF4-FFF2-40B4-BE49-F238E27FC236}">
-                <a16:creationId xmlns:a16="http://schemas.microsoft.com/office/drawing/2014/main" id="{204EB892-48B7-4948-A354-BB225BF4773F}"/>
-              </a:ext>
-            </a:extLst>
-          </p:cNvPr>
-          <p:cNvSpPr>
-            <a:spLocks noGrp="1"/>
-          </p:cNvSpPr>
-          <p:nvPr/>
-        </p:nvSpPr>
-        <p:spPr>
-          <a:xfrm>
-            <a:off x="685800" y="685800"/>
-            <a:ext cx="2857500" cy="228600"/>
-          </a:xfrm>
-          <a:prstGeom prst="rect">
-            <a:avLst/>
-          </a:prstGeom>
-          <a:noFill/>
-          <a:ln w="0">
-            <a:noFill/>
-            <a:prstDash val="solid"/>
-          </a:ln>
-        </p:spPr>
-        <p:txBody>
-          <a:bodyPr anchor="t"/>
-          <a:lstStyle/>
-          <a:p>
-            <a:pPr algn="l">
-              <a:defRPr sz="1125" b="1">
-                <a:solidFill>
-                  <a:srgbClr val="2F5D8C"/>
-                </a:solidFill>
-                <a:latin typeface="Aptos"/>
-                <a:ea typeface="Aptos"/>
-                <a:cs typeface="Aptos"/>
-              </a:defRPr>
-            </a:pPr>
-            <a:r>
-              <a:rPr sz="1125" b="1">
-                <a:solidFill>
-                  <a:srgbClr val="2F5D8C"/>
-                </a:solidFill>
-                <a:latin typeface="Aptos"/>
-                <a:ea typeface="Aptos"/>
-                <a:cs typeface="Aptos"/>
-              </a:rPr>
-              <a:t>SÍNTESE</a:t>
-            </a:r>
-          </a:p>
-        </p:txBody>
-      </p:sp>
-      <p:sp>
-        <p:nvSpPr>
-          <p:cNvPr id="3" name="Retângulo 2">
-            <a:extLst>
-              <a:ext uri="{FF2B5EF4-FFF2-40B4-BE49-F238E27FC236}">
-                <a16:creationId xmlns:a16="http://schemas.microsoft.com/office/drawing/2014/main" id="{903DB0B7-ECA4-4B30-B2FC-241A6CA28ACC}"/>
-              </a:ext>
-            </a:extLst>
-          </p:cNvPr>
-          <p:cNvSpPr>
-            <a:spLocks noGrp="1"/>
-          </p:cNvSpPr>
-          <p:nvPr/>
-        </p:nvSpPr>
-        <p:spPr>
-          <a:xfrm>
-            <a:off x="685800" y="1009650"/>
-            <a:ext cx="10287000" cy="533400"/>
-          </a:xfrm>
-          <a:prstGeom prst="rect">
-            <a:avLst/>
-          </a:prstGeom>
-          <a:noFill/>
-          <a:ln w="0">
-            <a:noFill/>
-            <a:prstDash val="solid"/>
-          </a:ln>
-        </p:spPr>
-        <p:txBody>
-          <a:bodyPr anchor="t"/>
-          <a:lstStyle/>
-          <a:p>
-            <a:pPr algn="l">
-              <a:defRPr sz="2625" b="1">
-                <a:solidFill>
-                  <a:srgbClr val="14213D"/>
-                </a:solidFill>
-                <a:latin typeface="Aptos"/>
-                <a:ea typeface="Aptos"/>
-                <a:cs typeface="Aptos"/>
-              </a:defRPr>
-            </a:pPr>
-            <a:r>
-              <a:rPr sz="2625" b="1">
-                <a:solidFill>
-                  <a:srgbClr val="14213D"/>
-                </a:solidFill>
-                <a:latin typeface="Aptos"/>
-                <a:ea typeface="Aptos"/>
-                <a:cs typeface="Aptos"/>
-              </a:rPr>
-              <a:t>A contribuição do AT é organizar eficiência, adaptação e auditoria em um único ciclo</a:t>
-            </a:r>
-          </a:p>
-        </p:txBody>
-      </p:sp>
-      <p:sp>
-        <p:nvSpPr>
-          <p:cNvPr id="4" name="Retângulo 3">
-            <a:extLst>
-              <a:ext uri="{FF2B5EF4-FFF2-40B4-BE49-F238E27FC236}">
-                <a16:creationId xmlns:a16="http://schemas.microsoft.com/office/drawing/2014/main" id="{2F3A5D8F-C5A7-454E-A30D-DABF3AD6E9AA}"/>
-              </a:ext>
-            </a:extLst>
-          </p:cNvPr>
-          <p:cNvSpPr>
-            <a:spLocks noGrp="1"/>
-          </p:cNvSpPr>
-          <p:nvPr/>
-        </p:nvSpPr>
-        <p:spPr>
-          <a:xfrm>
-            <a:off x="10953750" y="685800"/>
-            <a:ext cx="533400" cy="266700"/>
-          </a:xfrm>
-          <a:prstGeom prst="rect">
-            <a:avLst/>
-          </a:prstGeom>
-          <a:noFill/>
-          <a:ln w="0">
-            <a:noFill/>
-            <a:prstDash val="solid"/>
-          </a:ln>
-        </p:spPr>
-        <p:txBody>
-          <a:bodyPr anchor="t"/>
-          <a:lstStyle/>
-          <a:p>
-            <a:pPr algn="r">
-              <a:defRPr sz="1200" b="1">
-                <a:solidFill>
-                  <a:srgbClr val="5E6B7A"/>
-                </a:solidFill>
-                <a:latin typeface="Aptos"/>
-                <a:ea typeface="Aptos"/>
-                <a:cs typeface="Aptos"/>
-              </a:defRPr>
-            </a:pPr>
-            <a:r>
-              <a:rPr sz="1200" b="1">
-                <a:solidFill>
-                  <a:srgbClr val="5E6B7A"/>
-                </a:solidFill>
-                <a:latin typeface="Aptos"/>
-                <a:ea typeface="Aptos"/>
-                <a:cs typeface="Aptos"/>
-              </a:rPr>
               <a:t>12</a:t>
             </a:r>
           </a:p>
@@ -5661,118 +2371,6 @@
                 <a:cs typeface="Aptos"/>
               </a:rPr>
               <a:t>Usar representação adequada e bleaching para robustez, com suporte teórico.</a:t>
-            </a:r>
-          </a:p>
-        </p:txBody>
-      </p:sp>
-      <p:sp>
-        <p:nvSpPr>
-          <p:cNvPr id="9" name="Retângulo 8">
-            <a:extLst>
-              <a:ext uri="{FF2B5EF4-FFF2-40B4-BE49-F238E27FC236}">
-                <a16:creationId xmlns:a16="http://schemas.microsoft.com/office/drawing/2014/main" id="{EA984989-A29B-49E5-B702-C89967A471BA}"/>
-              </a:ext>
-            </a:extLst>
-          </p:cNvPr>
-          <p:cNvSpPr>
-            <a:spLocks noGrp="1"/>
-          </p:cNvSpPr>
-          <p:nvPr/>
-        </p:nvSpPr>
-        <p:spPr>
-          <a:xfrm>
-            <a:off x="1000125" y="4000500"/>
-            <a:ext cx="1095375" cy="285750"/>
-          </a:xfrm>
-          <a:prstGeom prst="rect">
-            <a:avLst/>
-          </a:prstGeom>
-          <a:noFill/>
-          <a:ln w="0">
-            <a:noFill/>
-            <a:prstDash val="solid"/>
-          </a:ln>
-        </p:spPr>
-        <p:txBody>
-          <a:bodyPr anchor="t"/>
-          <a:lstStyle/>
-          <a:p>
-            <a:pPr algn="l">
-              <a:defRPr sz="1650" b="1">
-                <a:solidFill>
-                  <a:srgbClr val="D96C4B"/>
-                </a:solidFill>
-                <a:latin typeface="Aptos"/>
-                <a:ea typeface="Aptos"/>
-                <a:cs typeface="Aptos"/>
-              </a:defRPr>
-            </a:pPr>
-            <a:r>
-              <a:rPr sz="1650" b="1">
-                <a:solidFill>
-                  <a:srgbClr val="D96C4B"/>
-                </a:solidFill>
-                <a:latin typeface="Aptos"/>
-                <a:ea typeface="Aptos"/>
-                <a:cs typeface="Aptos"/>
-              </a:rPr>
-              <a:t>AT</a:t>
-            </a:r>
-          </a:p>
-        </p:txBody>
-      </p:sp>
-      <p:sp>
-        <p:nvSpPr>
-          <p:cNvPr id="10" name="Retângulo 9">
-            <a:extLst>
-              <a:ext uri="{FF2B5EF4-FFF2-40B4-BE49-F238E27FC236}">
-                <a16:creationId xmlns:a16="http://schemas.microsoft.com/office/drawing/2014/main" id="{80EDCED9-F940-45A3-8800-6BBF2DE9FE5D}"/>
-              </a:ext>
-            </a:extLst>
-          </p:cNvPr>
-          <p:cNvSpPr>
-            <a:spLocks noGrp="1"/>
-          </p:cNvSpPr>
-          <p:nvPr/>
-        </p:nvSpPr>
-        <p:spPr>
-          <a:xfrm>
-            <a:off x="2381250" y="4000500"/>
-            <a:ext cx="7620000" cy="476250"/>
-          </a:xfrm>
-          <a:prstGeom prst="rect">
-            <a:avLst/>
-          </a:prstGeom>
-          <a:noFill/>
-          <a:ln w="0">
-            <a:noFill/>
-            <a:prstDash val="solid"/>
-          </a:ln>
-        </p:spPr>
-        <p:txBody>
-          <a:bodyPr anchor="t"/>
-          <a:lstStyle/>
-          <a:p>
-            <a:pPr algn="l">
-              <a:defRPr sz="1725" b="0">
-                <a:solidFill>
-                  <a:srgbClr val="14213D"/>
-                </a:solidFill>
-                <a:latin typeface="Aptos"/>
-                <a:ea typeface="Aptos"/>
-                <a:cs typeface="Aptos"/>
-              </a:defRPr>
-            </a:pPr>
-            <a:r>
-              <a:rPr sz="1725" b="0">
-                <a:solidFill>
-                  <a:srgbClr val="14213D"/>
-                </a:solidFill>
-                <a:latin typeface="Aptos"/>
-                <a:ea typeface="Aptos"/>
-                <a:cs typeface="Aptos"/>
-              </a:rPr>
-              <a:t>Aplicar uma memória textual explícita; reservar a LLM para o que exige contexto.</a:t>
             </a:r>
           </a:p>
         </p:txBody>
@@ -6191,6 +2789,12 @@
               <a:rPr lang="pt-PT" sz="2400" dirty="0"/>
               <a:t>- Fabio Rangel, Fabricio Firmino, Priscila Machado Vieira Lima e Jonice Oliveira (2016).</a:t>
             </a:r>
+          </a:p>
+          <a:p>
+            <a:pPr marL="342900" indent="-342900">
+              <a:buAutoNum type="arabicPeriod"/>
+            </a:pPr>
+            <a:endParaRPr lang="pt-PT" sz="2400" dirty="0"/>
           </a:p>
           <a:p>
             <a:pPr marL="342900" indent="-342900">
@@ -12125,7 +8729,7 @@
         </p:nvSpPr>
         <p:spPr>
           <a:xfrm>
-            <a:off x="952500" y="2476500"/>
+            <a:off x="1693164" y="2476500"/>
             <a:ext cx="2381250" cy="1428750"/>
           </a:xfrm>
           <a:prstGeom prst="roundRect">
@@ -12167,7 +8771,7 @@
         </p:nvSpPr>
         <p:spPr>
           <a:xfrm>
-            <a:off x="1162050" y="2857500"/>
+            <a:off x="1902714" y="2857500"/>
             <a:ext cx="1905000" cy="285750"/>
           </a:xfrm>
           <a:prstGeom prst="rect">
@@ -12223,7 +8827,7 @@
         </p:nvSpPr>
         <p:spPr>
           <a:xfrm>
-            <a:off x="1162050" y="3305175"/>
+            <a:off x="1902714" y="3305175"/>
             <a:ext cx="1905000" cy="228600"/>
           </a:xfrm>
           <a:prstGeom prst="rect">
@@ -12279,7 +8883,7 @@
         </p:nvSpPr>
         <p:spPr>
           <a:xfrm>
-            <a:off x="3409950" y="3000375"/>
+            <a:off x="4150614" y="3000375"/>
             <a:ext cx="514350" cy="266700"/>
           </a:xfrm>
           <a:prstGeom prst="rightArrow">
@@ -12319,7 +8923,7 @@
         </p:nvSpPr>
         <p:spPr>
           <a:xfrm>
-            <a:off x="4095750" y="2476500"/>
+            <a:off x="4836414" y="2476500"/>
             <a:ext cx="2381250" cy="1428750"/>
           </a:xfrm>
           <a:prstGeom prst="roundRect">
@@ -12361,7 +8965,7 @@
         </p:nvSpPr>
         <p:spPr>
           <a:xfrm>
-            <a:off x="4305300" y="2857500"/>
+            <a:off x="5045964" y="2857500"/>
             <a:ext cx="1905000" cy="285750"/>
           </a:xfrm>
           <a:prstGeom prst="rect">
@@ -12417,7 +9021,7 @@
         </p:nvSpPr>
         <p:spPr>
           <a:xfrm>
-            <a:off x="4305300" y="3305175"/>
+            <a:off x="5045964" y="3305175"/>
             <a:ext cx="1905000" cy="228600"/>
           </a:xfrm>
           <a:prstGeom prst="rect">
@@ -12473,7 +9077,7 @@
         </p:nvSpPr>
         <p:spPr>
           <a:xfrm>
-            <a:off x="6553200" y="3000375"/>
+            <a:off x="7293864" y="3000375"/>
             <a:ext cx="514350" cy="266700"/>
           </a:xfrm>
           <a:prstGeom prst="rightArrow">
@@ -12513,7 +9117,7 @@
         </p:nvSpPr>
         <p:spPr>
           <a:xfrm>
-            <a:off x="7239000" y="2476500"/>
+            <a:off x="7979664" y="2476500"/>
             <a:ext cx="2381250" cy="1428750"/>
           </a:xfrm>
           <a:prstGeom prst="roundRect">
@@ -12555,7 +9159,7 @@
         </p:nvSpPr>
         <p:spPr>
           <a:xfrm>
-            <a:off x="7448550" y="2857500"/>
+            <a:off x="8189214" y="2857500"/>
             <a:ext cx="1905000" cy="285750"/>
           </a:xfrm>
           <a:prstGeom prst="rect">
@@ -12611,7 +9215,7 @@
         </p:nvSpPr>
         <p:spPr>
           <a:xfrm>
-            <a:off x="7448550" y="3305175"/>
+            <a:off x="8189214" y="3305175"/>
             <a:ext cx="1905000" cy="228600"/>
           </a:xfrm>
           <a:prstGeom prst="rect">

</xml_diff>